<commit_message>
Add evaluated synthetic demand model and updated pitch
</commit_message>
<xml_diff>
--- a/slides/AllPower_Pitch_Deck.pptx
+++ b/slides/AllPower_Pitch_Deck.pptx
@@ -2,20 +2,20 @@
 <file path=ppt/presentation.xml><?xml version="1.0" encoding="utf-8"?>
 <p:presentation xmlns:p="http://schemas.openxmlformats.org/presentationml/2006/main">
   <p:sldMasterIdLst>
-    <p:sldMasterId xmlns:r="http://schemas.openxmlformats.org/officeDocument/2006/relationships" id="2147483648" r:id="R58f4a6cfcdc140f4"/>
+    <p:sldMasterId xmlns:r="http://schemas.openxmlformats.org/officeDocument/2006/relationships" id="2147483648" r:id="R08d78ac562454431"/>
   </p:sldMasterIdLst>
   <p:notesMasterIdLst>
-    <p:notesMasterId xmlns:r="http://schemas.openxmlformats.org/officeDocument/2006/relationships" r:id="R8b5eecb462a64130"/>
+    <p:notesMasterId xmlns:r="http://schemas.openxmlformats.org/officeDocument/2006/relationships" r:id="Rf66c0ea902974330"/>
   </p:notesMasterIdLst>
   <p:sldIdLst>
-    <p:sldId xmlns:r="http://schemas.openxmlformats.org/officeDocument/2006/relationships" id="256" r:id="R9244b7f004f34464"/>
-    <p:sldId xmlns:r="http://schemas.openxmlformats.org/officeDocument/2006/relationships" id="257" r:id="Rb602531e26104222"/>
-    <p:sldId xmlns:r="http://schemas.openxmlformats.org/officeDocument/2006/relationships" id="258" r:id="R0740352b39ae4686"/>
-    <p:sldId xmlns:r="http://schemas.openxmlformats.org/officeDocument/2006/relationships" id="259" r:id="Rc999399f17aa4b58"/>
-    <p:sldId xmlns:r="http://schemas.openxmlformats.org/officeDocument/2006/relationships" id="260" r:id="Rf04086abe5824020"/>
-    <p:sldId xmlns:r="http://schemas.openxmlformats.org/officeDocument/2006/relationships" id="261" r:id="R5bea4051dfa44d28"/>
-    <p:sldId xmlns:r="http://schemas.openxmlformats.org/officeDocument/2006/relationships" id="262" r:id="Rc5b8347399b74da1"/>
-    <p:sldId xmlns:r="http://schemas.openxmlformats.org/officeDocument/2006/relationships" id="263" r:id="R7a0b5351a20d4a3e"/>
+    <p:sldId xmlns:r="http://schemas.openxmlformats.org/officeDocument/2006/relationships" id="256" r:id="Ra03f6009c4b94d06"/>
+    <p:sldId xmlns:r="http://schemas.openxmlformats.org/officeDocument/2006/relationships" id="257" r:id="Re6a85db225a94f7b"/>
+    <p:sldId xmlns:r="http://schemas.openxmlformats.org/officeDocument/2006/relationships" id="258" r:id="Raeea0823568d4854"/>
+    <p:sldId xmlns:r="http://schemas.openxmlformats.org/officeDocument/2006/relationships" id="259" r:id="Rcf68ef2731c74878"/>
+    <p:sldId xmlns:r="http://schemas.openxmlformats.org/officeDocument/2006/relationships" id="260" r:id="Ref3006c75fd54794"/>
+    <p:sldId xmlns:r="http://schemas.openxmlformats.org/officeDocument/2006/relationships" id="261" r:id="R7025f1b03b3f47b9"/>
+    <p:sldId xmlns:r="http://schemas.openxmlformats.org/officeDocument/2006/relationships" id="262" r:id="R42a5c66fc4e34957"/>
+    <p:sldId xmlns:r="http://schemas.openxmlformats.org/officeDocument/2006/relationships" id="263" r:id="R8bdc328f56334ca6"/>
   </p:sldIdLst>
   <p:sldSz cx="12192000" cy="6858000"/>
   <p:notesSz cx="6858000" cy="9144000"/>
@@ -729,7 +729,7 @@
           <a:lstStyle xmlns:a="http://schemas.openxmlformats.org/drawingml/2006/main"/>
           <a:p xmlns:a="http://schemas.openxmlformats.org/drawingml/2006/main">
             <a:r>
-              <a:t>Do not cite invented accuracy. After real data is trained on LinuxONE, replace this slide with the saved MAE/RMSE and vision test metrics. The shipped demand model is a seasonal benchmark.</a:t>
+              <a:t>The 513–641 MW test MAE comes from the deterministic synthetic series only. It is not evidence of real ERCOT accuracy. After official data is trained on LinuxONE, replace this with saved real-data metrics and vision test results.</a:t>
             </a:r>
           </a:p>
         </p:txBody>
@@ -986,7 +986,7 @@
           <p:cNvPr id="3" name="Title">
             <a:extLst xmlns:a="http://schemas.openxmlformats.org/drawingml/2006/main">
               <a:ext uri="{FF2B5EF4-FFF2-40B4-BE49-F238E27FC236}">
-                <a16:creationId xmlns:a16="http://schemas.microsoft.com/office/drawing/2014/main" id="{22E7D5AE-9735-4CD1-A93A-FFF82259329D}"/>
+                <a16:creationId xmlns:a16="http://schemas.microsoft.com/office/drawing/2014/main" id="{D0076776-0808-4C13-B541-5F91A05A52B9}"/>
               </a:ext>
             </a:extLst>
           </p:cNvPr>
@@ -1143,7 +1143,7 @@
           <p:cNvPr id="2" name="Subtitle">
             <a:extLst xmlns:a="http://schemas.openxmlformats.org/drawingml/2006/main">
               <a:ext uri="{FF2B5EF4-FFF2-40B4-BE49-F238E27FC236}">
-                <a16:creationId xmlns:a16="http://schemas.microsoft.com/office/drawing/2014/main" id="{4C36E72F-EBF2-4FE5-B69D-48E783EA7332}"/>
+                <a16:creationId xmlns:a16="http://schemas.microsoft.com/office/drawing/2014/main" id="{119E9DB5-89AE-43B1-8D8E-853E01F9D739}"/>
               </a:ext>
             </a:extLst>
           </p:cNvPr>
@@ -1317,7 +1317,7 @@
           <p:cNvPr id="2" name="Section title">
             <a:extLst xmlns:a="http://schemas.openxmlformats.org/drawingml/2006/main">
               <a:ext uri="{FF2B5EF4-FFF2-40B4-BE49-F238E27FC236}">
-                <a16:creationId xmlns:a16="http://schemas.microsoft.com/office/drawing/2014/main" id="{5C567283-00BD-4198-806A-EC807380C054}"/>
+                <a16:creationId xmlns:a16="http://schemas.microsoft.com/office/drawing/2014/main" id="{7EECB308-4B50-4433-A2D3-CEE22CFB980E}"/>
               </a:ext>
             </a:extLst>
           </p:cNvPr>
@@ -1491,7 +1491,7 @@
           <p:cNvPr id="3" name="Title">
             <a:extLst xmlns:a="http://schemas.openxmlformats.org/drawingml/2006/main">
               <a:ext uri="{FF2B5EF4-FFF2-40B4-BE49-F238E27FC236}">
-                <a16:creationId xmlns:a16="http://schemas.microsoft.com/office/drawing/2014/main" id="{702BE5E0-F764-49E7-BE64-A3A43672CCB8}"/>
+                <a16:creationId xmlns:a16="http://schemas.microsoft.com/office/drawing/2014/main" id="{BCEE7F22-E65D-4E4F-9B34-55A6DCD29635}"/>
               </a:ext>
             </a:extLst>
           </p:cNvPr>
@@ -1648,7 +1648,7 @@
           <p:cNvPr id="2" name="Body">
             <a:extLst xmlns:a="http://schemas.openxmlformats.org/drawingml/2006/main">
               <a:ext uri="{FF2B5EF4-FFF2-40B4-BE49-F238E27FC236}">
-                <a16:creationId xmlns:a16="http://schemas.microsoft.com/office/drawing/2014/main" id="{49AA55C4-AC69-4F49-8B61-997E76CC3284}"/>
+                <a16:creationId xmlns:a16="http://schemas.microsoft.com/office/drawing/2014/main" id="{2F6D53F3-853A-49BD-AAF0-012D76E12174}"/>
               </a:ext>
             </a:extLst>
           </p:cNvPr>
@@ -1822,7 +1822,7 @@
           <p:cNvPr id="4" name="Title">
             <a:extLst xmlns:a="http://schemas.openxmlformats.org/drawingml/2006/main">
               <a:ext uri="{FF2B5EF4-FFF2-40B4-BE49-F238E27FC236}">
-                <a16:creationId xmlns:a16="http://schemas.microsoft.com/office/drawing/2014/main" id="{95AB20B5-E832-4824-9828-2AA9F0FC9810}"/>
+                <a16:creationId xmlns:a16="http://schemas.microsoft.com/office/drawing/2014/main" id="{9CC7D64A-C468-4A97-BB37-E3F1B54AB8EA}"/>
               </a:ext>
             </a:extLst>
           </p:cNvPr>
@@ -1979,7 +1979,7 @@
           <p:cNvPr id="2" name="Left column">
             <a:extLst xmlns:a="http://schemas.openxmlformats.org/drawingml/2006/main">
               <a:ext uri="{FF2B5EF4-FFF2-40B4-BE49-F238E27FC236}">
-                <a16:creationId xmlns:a16="http://schemas.microsoft.com/office/drawing/2014/main" id="{31A3063D-2AAA-4F6B-A0D1-740EC3ADBA1B}"/>
+                <a16:creationId xmlns:a16="http://schemas.microsoft.com/office/drawing/2014/main" id="{7BF596B9-7B09-4F17-B0C6-2B6580ACA06B}"/>
               </a:ext>
             </a:extLst>
           </p:cNvPr>
@@ -2136,7 +2136,7 @@
           <p:cNvPr id="3" name="Right column">
             <a:extLst xmlns:a="http://schemas.openxmlformats.org/drawingml/2006/main">
               <a:ext uri="{FF2B5EF4-FFF2-40B4-BE49-F238E27FC236}">
-                <a16:creationId xmlns:a16="http://schemas.microsoft.com/office/drawing/2014/main" id="{9AEE7875-BAD2-427E-A9F8-1B47A0E56BAE}"/>
+                <a16:creationId xmlns:a16="http://schemas.microsoft.com/office/drawing/2014/main" id="{1EB9F783-F470-4369-B50E-A4BE72B5B5CB}"/>
               </a:ext>
             </a:extLst>
           </p:cNvPr>
@@ -2310,7 +2310,7 @@
           <p:cNvPr id="3" name="Title">
             <a:extLst xmlns:a="http://schemas.openxmlformats.org/drawingml/2006/main">
               <a:ext uri="{FF2B5EF4-FFF2-40B4-BE49-F238E27FC236}">
-                <a16:creationId xmlns:a16="http://schemas.microsoft.com/office/drawing/2014/main" id="{CA070D71-2F31-4E13-85EC-0D0D98ED9F44}"/>
+                <a16:creationId xmlns:a16="http://schemas.microsoft.com/office/drawing/2014/main" id="{FCB48E71-2E64-47A1-A0C9-9A3A377C27B3}"/>
               </a:ext>
             </a:extLst>
           </p:cNvPr>
@@ -2467,7 +2467,7 @@
           <p:cNvPr id="2" name="Left column">
             <a:extLst xmlns:a="http://schemas.openxmlformats.org/drawingml/2006/main">
               <a:ext uri="{FF2B5EF4-FFF2-40B4-BE49-F238E27FC236}">
-                <a16:creationId xmlns:a16="http://schemas.microsoft.com/office/drawing/2014/main" id="{BE119147-D993-42E5-8D0D-2F9449894B67}"/>
+                <a16:creationId xmlns:a16="http://schemas.microsoft.com/office/drawing/2014/main" id="{29358443-4F47-4982-88FB-4BD73FF03291}"/>
               </a:ext>
             </a:extLst>
           </p:cNvPr>
@@ -2662,12 +2662,12 @@
   </p:cSld>
   <p:clrMap bg1="lt1" tx1="dk1" bg2="lt2" tx2="dk2" accent1="accent1" accent2="accent2" accent3="accent3" accent4="accent4" accent5="accent5" accent6="accent6" hlink="hlink" folHlink="folHlink"/>
   <p:sldLayoutIdLst>
-    <p:sldLayoutId xmlns:r="http://schemas.openxmlformats.org/officeDocument/2006/relationships" id="2147483649" r:id="R93d4cf0897bc49ea"/>
-    <p:sldLayoutId xmlns:r="http://schemas.openxmlformats.org/officeDocument/2006/relationships" id="2147483650" r:id="R6c722b2323b34df8"/>
-    <p:sldLayoutId xmlns:r="http://schemas.openxmlformats.org/officeDocument/2006/relationships" id="2147483651" r:id="R4b80ea6069ac4a39"/>
-    <p:sldLayoutId xmlns:r="http://schemas.openxmlformats.org/officeDocument/2006/relationships" id="2147483652" r:id="R57858e9b15cf4979"/>
-    <p:sldLayoutId xmlns:r="http://schemas.openxmlformats.org/officeDocument/2006/relationships" id="2147483653" r:id="R95d93b2ca1cc4723"/>
-    <p:sldLayoutId xmlns:r="http://schemas.openxmlformats.org/officeDocument/2006/relationships" id="2147483654" r:id="Rf85ec65275af4ef3"/>
+    <p:sldLayoutId xmlns:r="http://schemas.openxmlformats.org/officeDocument/2006/relationships" id="2147483649" r:id="R016099259e634247"/>
+    <p:sldLayoutId xmlns:r="http://schemas.openxmlformats.org/officeDocument/2006/relationships" id="2147483650" r:id="R03434be83d76475c"/>
+    <p:sldLayoutId xmlns:r="http://schemas.openxmlformats.org/officeDocument/2006/relationships" id="2147483651" r:id="R8568761a62bd469a"/>
+    <p:sldLayoutId xmlns:r="http://schemas.openxmlformats.org/officeDocument/2006/relationships" id="2147483652" r:id="Rf19cf3cd4686436b"/>
+    <p:sldLayoutId xmlns:r="http://schemas.openxmlformats.org/officeDocument/2006/relationships" id="2147483653" r:id="Rd8e31c94ebf84095"/>
+    <p:sldLayoutId xmlns:r="http://schemas.openxmlformats.org/officeDocument/2006/relationships" id="2147483654" r:id="R81b140a849f34442"/>
   </p:sldLayoutIdLst>
   <p:txStyles>
     <p:titleStyle>
@@ -3218,7 +3218,7 @@
           <p:cNvPr id="11" name="">
             <a:extLst xmlns:a="http://schemas.openxmlformats.org/drawingml/2006/main">
               <a:ext uri="{FF2B5EF4-FFF2-40B4-BE49-F238E27FC236}">
-                <a16:creationId xmlns:a16="http://schemas.microsoft.com/office/drawing/2014/main" id="{BAD57CC2-1856-4997-A262-C8D96CBC7C9B}"/>
+                <a16:creationId xmlns:a16="http://schemas.microsoft.com/office/drawing/2014/main" id="{CBED2861-B6C6-4F95-A4A7-4EE2C706AE44}"/>
               </a:ext>
             </a:extLst>
           </p:cNvPr>
@@ -3249,7 +3249,7 @@
           <p:cNvPr id="2" name="">
             <a:extLst xmlns:a="http://schemas.openxmlformats.org/drawingml/2006/main">
               <a:ext uri="{FF2B5EF4-FFF2-40B4-BE49-F238E27FC236}">
-                <a16:creationId xmlns:a16="http://schemas.microsoft.com/office/drawing/2014/main" id="{B7F09082-7686-4A59-A23B-D75BFC27B7B6}"/>
+                <a16:creationId xmlns:a16="http://schemas.microsoft.com/office/drawing/2014/main" id="{D892641C-A482-47E5-A716-CB9B12A39665}"/>
               </a:ext>
             </a:extLst>
           </p:cNvPr>
@@ -3307,7 +3307,7 @@
           <p:cNvPr id="3" name="">
             <a:extLst xmlns:a="http://schemas.openxmlformats.org/drawingml/2006/main">
               <a:ext uri="{FF2B5EF4-FFF2-40B4-BE49-F238E27FC236}">
-                <a16:creationId xmlns:a16="http://schemas.microsoft.com/office/drawing/2014/main" id="{D4CB4875-0850-4F0F-9EDD-FFE25C8C2057}"/>
+                <a16:creationId xmlns:a16="http://schemas.microsoft.com/office/drawing/2014/main" id="{B8AD6C9F-6C08-42F2-8B1F-5FD8FF6D4285}"/>
               </a:ext>
             </a:extLst>
           </p:cNvPr>
@@ -3365,7 +3365,7 @@
           <p:cNvPr id="4" name="">
             <a:extLst xmlns:a="http://schemas.openxmlformats.org/drawingml/2006/main">
               <a:ext uri="{FF2B5EF4-FFF2-40B4-BE49-F238E27FC236}">
-                <a16:creationId xmlns:a16="http://schemas.microsoft.com/office/drawing/2014/main" id="{A063E5BB-1551-4306-84A0-F0D12A8CB548}"/>
+                <a16:creationId xmlns:a16="http://schemas.microsoft.com/office/drawing/2014/main" id="{FBF1623E-7BA8-491F-9771-2CFBEF10C733}"/>
               </a:ext>
             </a:extLst>
           </p:cNvPr>
@@ -3396,7 +3396,7 @@
           <p:cNvPr id="5" name="">
             <a:extLst xmlns:a="http://schemas.openxmlformats.org/drawingml/2006/main">
               <a:ext uri="{FF2B5EF4-FFF2-40B4-BE49-F238E27FC236}">
-                <a16:creationId xmlns:a16="http://schemas.microsoft.com/office/drawing/2014/main" id="{18587B01-9FFA-442D-A1EA-4C43013424D2}"/>
+                <a16:creationId xmlns:a16="http://schemas.microsoft.com/office/drawing/2014/main" id="{D07FFC67-A6FD-46B0-8FCA-8B5060E53B3A}"/>
               </a:ext>
             </a:extLst>
           </p:cNvPr>
@@ -3454,7 +3454,7 @@
           <p:cNvPr id="6" name="">
             <a:extLst xmlns:a="http://schemas.openxmlformats.org/drawingml/2006/main">
               <a:ext uri="{FF2B5EF4-FFF2-40B4-BE49-F238E27FC236}">
-                <a16:creationId xmlns:a16="http://schemas.microsoft.com/office/drawing/2014/main" id="{E27748A0-0C95-4BE2-AE10-F733F8A8EE0E}"/>
+                <a16:creationId xmlns:a16="http://schemas.microsoft.com/office/drawing/2014/main" id="{89BF1D9F-6975-4452-A01D-F82EA01FFC96}"/>
               </a:ext>
             </a:extLst>
           </p:cNvPr>
@@ -3512,7 +3512,7 @@
           <p:cNvPr id="7" name="">
             <a:extLst xmlns:a="http://schemas.openxmlformats.org/drawingml/2006/main">
               <a:ext uri="{FF2B5EF4-FFF2-40B4-BE49-F238E27FC236}">
-                <a16:creationId xmlns:a16="http://schemas.microsoft.com/office/drawing/2014/main" id="{F0C69E57-72FA-42D3-B26D-0F2374F39219}"/>
+                <a16:creationId xmlns:a16="http://schemas.microsoft.com/office/drawing/2014/main" id="{6F5CDEC2-2151-4915-8992-277F8F99A2E6}"/>
               </a:ext>
             </a:extLst>
           </p:cNvPr>
@@ -3570,7 +3570,7 @@
           <p:cNvPr id="8" name="">
             <a:extLst xmlns:a="http://schemas.openxmlformats.org/drawingml/2006/main">
               <a:ext uri="{FF2B5EF4-FFF2-40B4-BE49-F238E27FC236}">
-                <a16:creationId xmlns:a16="http://schemas.microsoft.com/office/drawing/2014/main" id="{359508EE-9BF0-4D73-B23F-FD07EBC74EBA}"/>
+                <a16:creationId xmlns:a16="http://schemas.microsoft.com/office/drawing/2014/main" id="{F188F55B-C34F-466C-B30B-09DEA5EF7FBC}"/>
               </a:ext>
             </a:extLst>
           </p:cNvPr>
@@ -3601,7 +3601,7 @@
           <p:cNvPr id="9" name="">
             <a:extLst xmlns:a="http://schemas.openxmlformats.org/drawingml/2006/main">
               <a:ext uri="{FF2B5EF4-FFF2-40B4-BE49-F238E27FC236}">
-                <a16:creationId xmlns:a16="http://schemas.microsoft.com/office/drawing/2014/main" id="{1F8B68C7-4AEB-4635-B6F2-100ED4EC2597}"/>
+                <a16:creationId xmlns:a16="http://schemas.microsoft.com/office/drawing/2014/main" id="{FD522C71-D7A8-4DD7-822E-B9B16C2496C1}"/>
               </a:ext>
             </a:extLst>
           </p:cNvPr>
@@ -3659,7 +3659,7 @@
           <p:cNvPr id="10" name="">
             <a:extLst xmlns:a="http://schemas.openxmlformats.org/drawingml/2006/main">
               <a:ext uri="{FF2B5EF4-FFF2-40B4-BE49-F238E27FC236}">
-                <a16:creationId xmlns:a16="http://schemas.microsoft.com/office/drawing/2014/main" id="{5C49A41E-45E2-4163-8275-1617F8B250FB}"/>
+                <a16:creationId xmlns:a16="http://schemas.microsoft.com/office/drawing/2014/main" id="{AFA67FB0-989F-4ADB-907E-CA186257F4B3}"/>
               </a:ext>
             </a:extLst>
           </p:cNvPr>
@@ -3715,7 +3715,7 @@
     </p:spTree>
     <p:extLst>
       <p:ext uri="{BB962C8B-B14F-4D97-AF65-F5344CB8AC3E}">
-        <p14:creationId xmlns:p14="http://schemas.microsoft.com/office/powerpoint/2010/main" val="1820471059"/>
+        <p14:creationId xmlns:p14="http://schemas.microsoft.com/office/powerpoint/2010/main" val="411026345"/>
       </p:ext>
     </p:extLst>
   </p:cSld>
@@ -3746,7 +3746,7 @@
           <p:cNvPr id="20" name="">
             <a:extLst xmlns:a="http://schemas.openxmlformats.org/drawingml/2006/main">
               <a:ext uri="{FF2B5EF4-FFF2-40B4-BE49-F238E27FC236}">
-                <a16:creationId xmlns:a16="http://schemas.microsoft.com/office/drawing/2014/main" id="{7AE297B7-5C4E-4A42-8E38-AC78FCCDD9D3}"/>
+                <a16:creationId xmlns:a16="http://schemas.microsoft.com/office/drawing/2014/main" id="{F904A69E-854E-415A-871C-DAA04792610F}"/>
               </a:ext>
             </a:extLst>
           </p:cNvPr>
@@ -3777,7 +3777,7 @@
           <p:cNvPr id="2" name="">
             <a:extLst xmlns:a="http://schemas.openxmlformats.org/drawingml/2006/main">
               <a:ext uri="{FF2B5EF4-FFF2-40B4-BE49-F238E27FC236}">
-                <a16:creationId xmlns:a16="http://schemas.microsoft.com/office/drawing/2014/main" id="{DE26BF64-9635-43F1-BF42-1C72E912C7D6}"/>
+                <a16:creationId xmlns:a16="http://schemas.microsoft.com/office/drawing/2014/main" id="{B71BC4F9-7946-46E7-8C3E-E92EF7EF7557}"/>
               </a:ext>
             </a:extLst>
           </p:cNvPr>
@@ -3835,7 +3835,7 @@
           <p:cNvPr id="3" name="">
             <a:extLst xmlns:a="http://schemas.openxmlformats.org/drawingml/2006/main">
               <a:ext uri="{FF2B5EF4-FFF2-40B4-BE49-F238E27FC236}">
-                <a16:creationId xmlns:a16="http://schemas.microsoft.com/office/drawing/2014/main" id="{8BAA1880-37AB-4418-AB1F-263FECBC081B}"/>
+                <a16:creationId xmlns:a16="http://schemas.microsoft.com/office/drawing/2014/main" id="{3CEB7C5C-DAE1-48C8-8124-2B43E340069B}"/>
               </a:ext>
             </a:extLst>
           </p:cNvPr>
@@ -3893,7 +3893,7 @@
           <p:cNvPr id="4" name="">
             <a:extLst xmlns:a="http://schemas.openxmlformats.org/drawingml/2006/main">
               <a:ext uri="{FF2B5EF4-FFF2-40B4-BE49-F238E27FC236}">
-                <a16:creationId xmlns:a16="http://schemas.microsoft.com/office/drawing/2014/main" id="{C6B0AA85-BE8F-4FBF-A66A-166FC308EE90}"/>
+                <a16:creationId xmlns:a16="http://schemas.microsoft.com/office/drawing/2014/main" id="{66D115F3-D5F7-43C3-9221-989FEBDB295D}"/>
               </a:ext>
             </a:extLst>
           </p:cNvPr>
@@ -3924,7 +3924,7 @@
           <p:cNvPr id="5" name="">
             <a:extLst xmlns:a="http://schemas.openxmlformats.org/drawingml/2006/main">
               <a:ext uri="{FF2B5EF4-FFF2-40B4-BE49-F238E27FC236}">
-                <a16:creationId xmlns:a16="http://schemas.microsoft.com/office/drawing/2014/main" id="{881EFEC3-95F7-474D-A085-C18FE97A47CC}"/>
+                <a16:creationId xmlns:a16="http://schemas.microsoft.com/office/drawing/2014/main" id="{437F981D-F0DD-4FD7-8152-8FAEA36476AE}"/>
               </a:ext>
             </a:extLst>
           </p:cNvPr>
@@ -3982,7 +3982,7 @@
           <p:cNvPr id="6" name="">
             <a:extLst xmlns:a="http://schemas.openxmlformats.org/drawingml/2006/main">
               <a:ext uri="{FF2B5EF4-FFF2-40B4-BE49-F238E27FC236}">
-                <a16:creationId xmlns:a16="http://schemas.microsoft.com/office/drawing/2014/main" id="{97578573-1E07-49AA-BFA6-54C58ADE87A8}"/>
+                <a16:creationId xmlns:a16="http://schemas.microsoft.com/office/drawing/2014/main" id="{8DF9D021-D5C6-4E30-B97F-AE72ABB223CB}"/>
               </a:ext>
             </a:extLst>
           </p:cNvPr>
@@ -4040,7 +4040,7 @@
           <p:cNvPr id="7" name="">
             <a:extLst xmlns:a="http://schemas.openxmlformats.org/drawingml/2006/main">
               <a:ext uri="{FF2B5EF4-FFF2-40B4-BE49-F238E27FC236}">
-                <a16:creationId xmlns:a16="http://schemas.microsoft.com/office/drawing/2014/main" id="{D64682E7-5151-44DE-A29D-C50C130DE89F}"/>
+                <a16:creationId xmlns:a16="http://schemas.microsoft.com/office/drawing/2014/main" id="{F852376A-F996-415C-8450-B4FAE4A55056}"/>
               </a:ext>
             </a:extLst>
           </p:cNvPr>
@@ -4098,7 +4098,7 @@
           <p:cNvPr id="8" name="">
             <a:extLst xmlns:a="http://schemas.openxmlformats.org/drawingml/2006/main">
               <a:ext uri="{FF2B5EF4-FFF2-40B4-BE49-F238E27FC236}">
-                <a16:creationId xmlns:a16="http://schemas.microsoft.com/office/drawing/2014/main" id="{D12A8FCB-FF91-41EE-943D-68B802C6ACE1}"/>
+                <a16:creationId xmlns:a16="http://schemas.microsoft.com/office/drawing/2014/main" id="{7DB124EB-2640-400F-AB48-7A4BC5B446AC}"/>
               </a:ext>
             </a:extLst>
           </p:cNvPr>
@@ -4129,7 +4129,7 @@
           <p:cNvPr id="9" name="">
             <a:extLst xmlns:a="http://schemas.openxmlformats.org/drawingml/2006/main">
               <a:ext uri="{FF2B5EF4-FFF2-40B4-BE49-F238E27FC236}">
-                <a16:creationId xmlns:a16="http://schemas.microsoft.com/office/drawing/2014/main" id="{660310E8-3DC1-4D72-98F4-4BB631BDDEE5}"/>
+                <a16:creationId xmlns:a16="http://schemas.microsoft.com/office/drawing/2014/main" id="{CBC0A4E8-0F3E-484C-9305-9C817972884A}"/>
               </a:ext>
             </a:extLst>
           </p:cNvPr>
@@ -4187,7 +4187,7 @@
           <p:cNvPr id="10" name="">
             <a:extLst xmlns:a="http://schemas.openxmlformats.org/drawingml/2006/main">
               <a:ext uri="{FF2B5EF4-FFF2-40B4-BE49-F238E27FC236}">
-                <a16:creationId xmlns:a16="http://schemas.microsoft.com/office/drawing/2014/main" id="{6D2EFF55-35D9-4F3C-B980-9237EDEDE006}"/>
+                <a16:creationId xmlns:a16="http://schemas.microsoft.com/office/drawing/2014/main" id="{F0966A3D-B04E-4D24-959C-73A22849848E}"/>
               </a:ext>
             </a:extLst>
           </p:cNvPr>
@@ -4245,7 +4245,7 @@
           <p:cNvPr id="11" name="">
             <a:extLst xmlns:a="http://schemas.openxmlformats.org/drawingml/2006/main">
               <a:ext uri="{FF2B5EF4-FFF2-40B4-BE49-F238E27FC236}">
-                <a16:creationId xmlns:a16="http://schemas.microsoft.com/office/drawing/2014/main" id="{9E1FC16D-77DA-4F41-94A8-781CD1FA6ACE}"/>
+                <a16:creationId xmlns:a16="http://schemas.microsoft.com/office/drawing/2014/main" id="{98A7CD55-C991-41E2-B279-E2164B6F1EDC}"/>
               </a:ext>
             </a:extLst>
           </p:cNvPr>
@@ -4303,7 +4303,7 @@
           <p:cNvPr id="12" name="">
             <a:extLst xmlns:a="http://schemas.openxmlformats.org/drawingml/2006/main">
               <a:ext uri="{FF2B5EF4-FFF2-40B4-BE49-F238E27FC236}">
-                <a16:creationId xmlns:a16="http://schemas.microsoft.com/office/drawing/2014/main" id="{3D256643-1CFD-4551-B106-7646C1BF3AAC}"/>
+                <a16:creationId xmlns:a16="http://schemas.microsoft.com/office/drawing/2014/main" id="{06510FFD-2375-44D6-8786-04B7F5968B29}"/>
               </a:ext>
             </a:extLst>
           </p:cNvPr>
@@ -4334,7 +4334,7 @@
           <p:cNvPr id="13" name="">
             <a:extLst xmlns:a="http://schemas.openxmlformats.org/drawingml/2006/main">
               <a:ext uri="{FF2B5EF4-FFF2-40B4-BE49-F238E27FC236}">
-                <a16:creationId xmlns:a16="http://schemas.microsoft.com/office/drawing/2014/main" id="{130491A8-804D-4C36-835B-A7879A2368EB}"/>
+                <a16:creationId xmlns:a16="http://schemas.microsoft.com/office/drawing/2014/main" id="{CF9285C8-C4E0-4C5E-A40C-64E233E85EF2}"/>
               </a:ext>
             </a:extLst>
           </p:cNvPr>
@@ -4392,7 +4392,7 @@
           <p:cNvPr id="14" name="">
             <a:extLst xmlns:a="http://schemas.openxmlformats.org/drawingml/2006/main">
               <a:ext uri="{FF2B5EF4-FFF2-40B4-BE49-F238E27FC236}">
-                <a16:creationId xmlns:a16="http://schemas.microsoft.com/office/drawing/2014/main" id="{F76919C4-FC5A-45C0-AC02-F3EDA8DC50F1}"/>
+                <a16:creationId xmlns:a16="http://schemas.microsoft.com/office/drawing/2014/main" id="{CE03BC38-4F60-4846-B3A5-B6478F8DEA0D}"/>
               </a:ext>
             </a:extLst>
           </p:cNvPr>
@@ -4450,7 +4450,7 @@
           <p:cNvPr id="15" name="">
             <a:extLst xmlns:a="http://schemas.openxmlformats.org/drawingml/2006/main">
               <a:ext uri="{FF2B5EF4-FFF2-40B4-BE49-F238E27FC236}">
-                <a16:creationId xmlns:a16="http://schemas.microsoft.com/office/drawing/2014/main" id="{D4A54716-2100-453E-A5AB-B4549615B683}"/>
+                <a16:creationId xmlns:a16="http://schemas.microsoft.com/office/drawing/2014/main" id="{63C75915-E576-416D-B0EA-9FA437F8FEE6}"/>
               </a:ext>
             </a:extLst>
           </p:cNvPr>
@@ -4508,7 +4508,7 @@
           <p:cNvPr id="16" name="">
             <a:extLst xmlns:a="http://schemas.openxmlformats.org/drawingml/2006/main">
               <a:ext uri="{FF2B5EF4-FFF2-40B4-BE49-F238E27FC236}">
-                <a16:creationId xmlns:a16="http://schemas.microsoft.com/office/drawing/2014/main" id="{99FAE77A-84D8-4BC1-B5F2-12E39AEA26D0}"/>
+                <a16:creationId xmlns:a16="http://schemas.microsoft.com/office/drawing/2014/main" id="{9658883C-81AF-4D7D-9036-CFCC96E4472E}"/>
               </a:ext>
             </a:extLst>
           </p:cNvPr>
@@ -4539,7 +4539,7 @@
           <p:cNvPr id="17" name="">
             <a:extLst xmlns:a="http://schemas.openxmlformats.org/drawingml/2006/main">
               <a:ext uri="{FF2B5EF4-FFF2-40B4-BE49-F238E27FC236}">
-                <a16:creationId xmlns:a16="http://schemas.microsoft.com/office/drawing/2014/main" id="{6169D345-6087-4448-872F-1144D797C865}"/>
+                <a16:creationId xmlns:a16="http://schemas.microsoft.com/office/drawing/2014/main" id="{181FD3EA-D2F1-4600-9786-EF35621E25ED}"/>
               </a:ext>
             </a:extLst>
           </p:cNvPr>
@@ -4597,7 +4597,7 @@
           <p:cNvPr id="18" name="">
             <a:extLst xmlns:a="http://schemas.openxmlformats.org/drawingml/2006/main">
               <a:ext uri="{FF2B5EF4-FFF2-40B4-BE49-F238E27FC236}">
-                <a16:creationId xmlns:a16="http://schemas.microsoft.com/office/drawing/2014/main" id="{C0E2E39D-0289-446D-AAEB-1008BDF027CE}"/>
+                <a16:creationId xmlns:a16="http://schemas.microsoft.com/office/drawing/2014/main" id="{E50D58E2-F441-43F1-8E10-F8A6F4369803}"/>
               </a:ext>
             </a:extLst>
           </p:cNvPr>
@@ -4655,7 +4655,7 @@
           <p:cNvPr id="19" name="">
             <a:extLst xmlns:a="http://schemas.openxmlformats.org/drawingml/2006/main">
               <a:ext uri="{FF2B5EF4-FFF2-40B4-BE49-F238E27FC236}">
-                <a16:creationId xmlns:a16="http://schemas.microsoft.com/office/drawing/2014/main" id="{C76B26BA-A74C-450F-B9D4-C4F22D84470A}"/>
+                <a16:creationId xmlns:a16="http://schemas.microsoft.com/office/drawing/2014/main" id="{C8D5E3E3-F06E-4C34-97F3-B7F2217241B5}"/>
               </a:ext>
             </a:extLst>
           </p:cNvPr>
@@ -4711,7 +4711,7 @@
     </p:spTree>
     <p:extLst>
       <p:ext uri="{BB962C8B-B14F-4D97-AF65-F5344CB8AC3E}">
-        <p14:creationId xmlns:p14="http://schemas.microsoft.com/office/powerpoint/2010/main" val="919580070"/>
+        <p14:creationId xmlns:p14="http://schemas.microsoft.com/office/powerpoint/2010/main" val="1210075626"/>
       </p:ext>
     </p:extLst>
   </p:cSld>
@@ -4742,7 +4742,7 @@
           <p:cNvPr id="24" name="">
             <a:extLst xmlns:a="http://schemas.openxmlformats.org/drawingml/2006/main">
               <a:ext uri="{FF2B5EF4-FFF2-40B4-BE49-F238E27FC236}">
-                <a16:creationId xmlns:a16="http://schemas.microsoft.com/office/drawing/2014/main" id="{4E178AB9-DD71-4953-9E1B-5D1140EA9C06}"/>
+                <a16:creationId xmlns:a16="http://schemas.microsoft.com/office/drawing/2014/main" id="{1DC32BB8-AFBA-48FB-8AF2-D199E2699F89}"/>
               </a:ext>
             </a:extLst>
           </p:cNvPr>
@@ -4773,7 +4773,7 @@
           <p:cNvPr id="2" name="">
             <a:extLst xmlns:a="http://schemas.openxmlformats.org/drawingml/2006/main">
               <a:ext uri="{FF2B5EF4-FFF2-40B4-BE49-F238E27FC236}">
-                <a16:creationId xmlns:a16="http://schemas.microsoft.com/office/drawing/2014/main" id="{475CAD42-AC2E-434D-9C22-3351374E55D5}"/>
+                <a16:creationId xmlns:a16="http://schemas.microsoft.com/office/drawing/2014/main" id="{EA744161-094E-4226-9FF0-9C37E3B70778}"/>
               </a:ext>
             </a:extLst>
           </p:cNvPr>
@@ -4831,7 +4831,7 @@
           <p:cNvPr id="3" name="">
             <a:extLst xmlns:a="http://schemas.openxmlformats.org/drawingml/2006/main">
               <a:ext uri="{FF2B5EF4-FFF2-40B4-BE49-F238E27FC236}">
-                <a16:creationId xmlns:a16="http://schemas.microsoft.com/office/drawing/2014/main" id="{8CB6F98F-9E0E-4888-9059-47E26C53C6CA}"/>
+                <a16:creationId xmlns:a16="http://schemas.microsoft.com/office/drawing/2014/main" id="{3CAD1E4E-BE83-42FD-A531-6FA43939D741}"/>
               </a:ext>
             </a:extLst>
           </p:cNvPr>
@@ -4889,7 +4889,7 @@
           <p:cNvPr id="4" name="">
             <a:extLst xmlns:a="http://schemas.openxmlformats.org/drawingml/2006/main">
               <a:ext uri="{FF2B5EF4-FFF2-40B4-BE49-F238E27FC236}">
-                <a16:creationId xmlns:a16="http://schemas.microsoft.com/office/drawing/2014/main" id="{0C21E2D2-385C-4429-952C-89D55DB46F3C}"/>
+                <a16:creationId xmlns:a16="http://schemas.microsoft.com/office/drawing/2014/main" id="{4D8B4484-5313-4A9C-B6C4-03DAF614B345}"/>
               </a:ext>
             </a:extLst>
           </p:cNvPr>
@@ -4920,7 +4920,7 @@
           <p:cNvPr id="5" name="">
             <a:extLst xmlns:a="http://schemas.openxmlformats.org/drawingml/2006/main">
               <a:ext uri="{FF2B5EF4-FFF2-40B4-BE49-F238E27FC236}">
-                <a16:creationId xmlns:a16="http://schemas.microsoft.com/office/drawing/2014/main" id="{C99E7FFA-769C-4686-89E1-2EB8F1509041}"/>
+                <a16:creationId xmlns:a16="http://schemas.microsoft.com/office/drawing/2014/main" id="{3601B84D-F7B5-485A-B0D2-747261FC980B}"/>
               </a:ext>
             </a:extLst>
           </p:cNvPr>
@@ -4978,7 +4978,7 @@
           <p:cNvPr id="6" name="">
             <a:extLst xmlns:a="http://schemas.openxmlformats.org/drawingml/2006/main">
               <a:ext uri="{FF2B5EF4-FFF2-40B4-BE49-F238E27FC236}">
-                <a16:creationId xmlns:a16="http://schemas.microsoft.com/office/drawing/2014/main" id="{86B261D0-4BF9-4735-8EA5-AADF41295D0E}"/>
+                <a16:creationId xmlns:a16="http://schemas.microsoft.com/office/drawing/2014/main" id="{83DFD330-E88A-4673-AEB5-7949FFF014A7}"/>
               </a:ext>
             </a:extLst>
           </p:cNvPr>
@@ -5036,7 +5036,7 @@
           <p:cNvPr id="7" name="">
             <a:extLst xmlns:a="http://schemas.openxmlformats.org/drawingml/2006/main">
               <a:ext uri="{FF2B5EF4-FFF2-40B4-BE49-F238E27FC236}">
-                <a16:creationId xmlns:a16="http://schemas.microsoft.com/office/drawing/2014/main" id="{CB24AAD6-467F-4EA5-B7B6-ADFA364E5C65}"/>
+                <a16:creationId xmlns:a16="http://schemas.microsoft.com/office/drawing/2014/main" id="{0DB5D810-DAFC-4C7C-8524-BBA59F20DEF8}"/>
               </a:ext>
             </a:extLst>
           </p:cNvPr>
@@ -5094,7 +5094,7 @@
           <p:cNvPr id="8" name="">
             <a:extLst xmlns:a="http://schemas.openxmlformats.org/drawingml/2006/main">
               <a:ext uri="{FF2B5EF4-FFF2-40B4-BE49-F238E27FC236}">
-                <a16:creationId xmlns:a16="http://schemas.microsoft.com/office/drawing/2014/main" id="{1B56DE8A-6E9B-42FA-AEA9-2B4325E226B7}"/>
+                <a16:creationId xmlns:a16="http://schemas.microsoft.com/office/drawing/2014/main" id="{FE7C1212-14DA-47A4-AE03-9B91DC4FD4CD}"/>
               </a:ext>
             </a:extLst>
           </p:cNvPr>
@@ -5125,7 +5125,7 @@
           <p:cNvPr id="9" name="">
             <a:extLst xmlns:a="http://schemas.openxmlformats.org/drawingml/2006/main">
               <a:ext uri="{FF2B5EF4-FFF2-40B4-BE49-F238E27FC236}">
-                <a16:creationId xmlns:a16="http://schemas.microsoft.com/office/drawing/2014/main" id="{B42601CE-931D-4E1A-BD41-3A7DFB2F9F46}"/>
+                <a16:creationId xmlns:a16="http://schemas.microsoft.com/office/drawing/2014/main" id="{A72965C1-0C00-4368-ABF7-81CE56DFF8E8}"/>
               </a:ext>
             </a:extLst>
           </p:cNvPr>
@@ -5183,7 +5183,7 @@
           <p:cNvPr id="10" name="">
             <a:extLst xmlns:a="http://schemas.openxmlformats.org/drawingml/2006/main">
               <a:ext uri="{FF2B5EF4-FFF2-40B4-BE49-F238E27FC236}">
-                <a16:creationId xmlns:a16="http://schemas.microsoft.com/office/drawing/2014/main" id="{EBB35CE5-A4F4-49B1-8757-8A464D522FC6}"/>
+                <a16:creationId xmlns:a16="http://schemas.microsoft.com/office/drawing/2014/main" id="{35E90410-24C2-4B7F-9647-34EC78F0E2E9}"/>
               </a:ext>
             </a:extLst>
           </p:cNvPr>
@@ -5241,7 +5241,7 @@
           <p:cNvPr id="11" name="">
             <a:extLst xmlns:a="http://schemas.openxmlformats.org/drawingml/2006/main">
               <a:ext uri="{FF2B5EF4-FFF2-40B4-BE49-F238E27FC236}">
-                <a16:creationId xmlns:a16="http://schemas.microsoft.com/office/drawing/2014/main" id="{F104D911-D2D6-41ED-83ED-51EF183EFBB1}"/>
+                <a16:creationId xmlns:a16="http://schemas.microsoft.com/office/drawing/2014/main" id="{15071A1A-43AD-4CB5-95A4-B40A62B17771}"/>
               </a:ext>
             </a:extLst>
           </p:cNvPr>
@@ -5299,7 +5299,7 @@
           <p:cNvPr id="12" name="">
             <a:extLst xmlns:a="http://schemas.openxmlformats.org/drawingml/2006/main">
               <a:ext uri="{FF2B5EF4-FFF2-40B4-BE49-F238E27FC236}">
-                <a16:creationId xmlns:a16="http://schemas.microsoft.com/office/drawing/2014/main" id="{D4FD1606-FCAD-419B-A0F0-BCF5CDD5CFDE}"/>
+                <a16:creationId xmlns:a16="http://schemas.microsoft.com/office/drawing/2014/main" id="{ADC3DF87-0035-4C54-A641-81992C60C2EE}"/>
               </a:ext>
             </a:extLst>
           </p:cNvPr>
@@ -5330,7 +5330,7 @@
           <p:cNvPr id="13" name="">
             <a:extLst xmlns:a="http://schemas.openxmlformats.org/drawingml/2006/main">
               <a:ext uri="{FF2B5EF4-FFF2-40B4-BE49-F238E27FC236}">
-                <a16:creationId xmlns:a16="http://schemas.microsoft.com/office/drawing/2014/main" id="{0C72CF01-DB4C-410A-98D6-85A3015D764B}"/>
+                <a16:creationId xmlns:a16="http://schemas.microsoft.com/office/drawing/2014/main" id="{42752978-A05E-42BB-9803-24EF511BFB32}"/>
               </a:ext>
             </a:extLst>
           </p:cNvPr>
@@ -5388,7 +5388,7 @@
           <p:cNvPr id="14" name="">
             <a:extLst xmlns:a="http://schemas.openxmlformats.org/drawingml/2006/main">
               <a:ext uri="{FF2B5EF4-FFF2-40B4-BE49-F238E27FC236}">
-                <a16:creationId xmlns:a16="http://schemas.microsoft.com/office/drawing/2014/main" id="{8AD309FA-44D9-4291-BADB-A46B877D299D}"/>
+                <a16:creationId xmlns:a16="http://schemas.microsoft.com/office/drawing/2014/main" id="{0200008E-99FC-4A6A-B306-70454D980AEA}"/>
               </a:ext>
             </a:extLst>
           </p:cNvPr>
@@ -5446,7 +5446,7 @@
           <p:cNvPr id="15" name="">
             <a:extLst xmlns:a="http://schemas.openxmlformats.org/drawingml/2006/main">
               <a:ext uri="{FF2B5EF4-FFF2-40B4-BE49-F238E27FC236}">
-                <a16:creationId xmlns:a16="http://schemas.microsoft.com/office/drawing/2014/main" id="{9D0B5272-CABF-452D-9743-88388C6D28D5}"/>
+                <a16:creationId xmlns:a16="http://schemas.microsoft.com/office/drawing/2014/main" id="{EEF125B5-FDFB-49C2-A157-D2AEF1F44AEB}"/>
               </a:ext>
             </a:extLst>
           </p:cNvPr>
@@ -5504,7 +5504,7 @@
           <p:cNvPr id="16" name="">
             <a:extLst xmlns:a="http://schemas.openxmlformats.org/drawingml/2006/main">
               <a:ext uri="{FF2B5EF4-FFF2-40B4-BE49-F238E27FC236}">
-                <a16:creationId xmlns:a16="http://schemas.microsoft.com/office/drawing/2014/main" id="{FBA25E8C-9C34-4A03-A590-F382E3EA6025}"/>
+                <a16:creationId xmlns:a16="http://schemas.microsoft.com/office/drawing/2014/main" id="{6846175F-C037-4C2E-97F2-D492E996CE68}"/>
               </a:ext>
             </a:extLst>
           </p:cNvPr>
@@ -5535,7 +5535,7 @@
           <p:cNvPr id="17" name="">
             <a:extLst xmlns:a="http://schemas.openxmlformats.org/drawingml/2006/main">
               <a:ext uri="{FF2B5EF4-FFF2-40B4-BE49-F238E27FC236}">
-                <a16:creationId xmlns:a16="http://schemas.microsoft.com/office/drawing/2014/main" id="{90754153-0BC5-49F2-9004-48E98E8ABF59}"/>
+                <a16:creationId xmlns:a16="http://schemas.microsoft.com/office/drawing/2014/main" id="{635BB9DC-6BBF-4250-8E98-EEAFB021DDE1}"/>
               </a:ext>
             </a:extLst>
           </p:cNvPr>
@@ -5593,7 +5593,7 @@
           <p:cNvPr id="18" name="">
             <a:extLst xmlns:a="http://schemas.openxmlformats.org/drawingml/2006/main">
               <a:ext uri="{FF2B5EF4-FFF2-40B4-BE49-F238E27FC236}">
-                <a16:creationId xmlns:a16="http://schemas.microsoft.com/office/drawing/2014/main" id="{0185342A-C803-4E84-8982-16E71A3666DD}"/>
+                <a16:creationId xmlns:a16="http://schemas.microsoft.com/office/drawing/2014/main" id="{7FF86573-7422-4384-AE54-02948480CB27}"/>
               </a:ext>
             </a:extLst>
           </p:cNvPr>
@@ -5651,7 +5651,7 @@
           <p:cNvPr id="19" name="">
             <a:extLst xmlns:a="http://schemas.openxmlformats.org/drawingml/2006/main">
               <a:ext uri="{FF2B5EF4-FFF2-40B4-BE49-F238E27FC236}">
-                <a16:creationId xmlns:a16="http://schemas.microsoft.com/office/drawing/2014/main" id="{FEC5C932-51F1-4B77-BB3A-0813254FD0A8}"/>
+                <a16:creationId xmlns:a16="http://schemas.microsoft.com/office/drawing/2014/main" id="{9096FBF1-0088-4040-8FAD-25BB3CD55CC8}"/>
               </a:ext>
             </a:extLst>
           </p:cNvPr>
@@ -5709,7 +5709,7 @@
           <p:cNvPr id="20" name="">
             <a:extLst xmlns:a="http://schemas.openxmlformats.org/drawingml/2006/main">
               <a:ext uri="{FF2B5EF4-FFF2-40B4-BE49-F238E27FC236}">
-                <a16:creationId xmlns:a16="http://schemas.microsoft.com/office/drawing/2014/main" id="{3C8CD665-96F1-4C07-845B-64DA13D79679}"/>
+                <a16:creationId xmlns:a16="http://schemas.microsoft.com/office/drawing/2014/main" id="{BB56538A-A692-4341-B943-E267A285A680}"/>
               </a:ext>
             </a:extLst>
           </p:cNvPr>
@@ -5740,7 +5740,7 @@
           <p:cNvPr id="21" name="">
             <a:extLst xmlns:a="http://schemas.openxmlformats.org/drawingml/2006/main">
               <a:ext uri="{FF2B5EF4-FFF2-40B4-BE49-F238E27FC236}">
-                <a16:creationId xmlns:a16="http://schemas.microsoft.com/office/drawing/2014/main" id="{8E1F031F-D2B4-47D6-9C63-2D577C8E0D25}"/>
+                <a16:creationId xmlns:a16="http://schemas.microsoft.com/office/drawing/2014/main" id="{49ABDBD5-FE8C-4208-A116-C0E2F1962011}"/>
               </a:ext>
             </a:extLst>
           </p:cNvPr>
@@ -5798,7 +5798,7 @@
           <p:cNvPr id="22" name="">
             <a:extLst xmlns:a="http://schemas.openxmlformats.org/drawingml/2006/main">
               <a:ext uri="{FF2B5EF4-FFF2-40B4-BE49-F238E27FC236}">
-                <a16:creationId xmlns:a16="http://schemas.microsoft.com/office/drawing/2014/main" id="{F68A510C-4A0C-48E2-A1EB-C0F5CDB72EE1}"/>
+                <a16:creationId xmlns:a16="http://schemas.microsoft.com/office/drawing/2014/main" id="{382EB7FE-E1B9-4E32-B8E7-33571F90A0C2}"/>
               </a:ext>
             </a:extLst>
           </p:cNvPr>
@@ -5856,7 +5856,7 @@
           <p:cNvPr id="23" name="">
             <a:extLst xmlns:a="http://schemas.openxmlformats.org/drawingml/2006/main">
               <a:ext uri="{FF2B5EF4-FFF2-40B4-BE49-F238E27FC236}">
-                <a16:creationId xmlns:a16="http://schemas.microsoft.com/office/drawing/2014/main" id="{3D45467C-7EB3-4AED-AFFB-BE8B11C6B218}"/>
+                <a16:creationId xmlns:a16="http://schemas.microsoft.com/office/drawing/2014/main" id="{AC1DA9FE-44FF-444F-8A2D-F7B196EE993A}"/>
               </a:ext>
             </a:extLst>
           </p:cNvPr>
@@ -5912,7 +5912,7 @@
     </p:spTree>
     <p:extLst>
       <p:ext uri="{BB962C8B-B14F-4D97-AF65-F5344CB8AC3E}">
-        <p14:creationId xmlns:p14="http://schemas.microsoft.com/office/powerpoint/2010/main" val="594438386"/>
+        <p14:creationId xmlns:p14="http://schemas.microsoft.com/office/powerpoint/2010/main" val="1278302520"/>
       </p:ext>
     </p:extLst>
   </p:cSld>
@@ -5943,7 +5943,7 @@
           <p:cNvPr id="20" name="">
             <a:extLst xmlns:a="http://schemas.openxmlformats.org/drawingml/2006/main">
               <a:ext uri="{FF2B5EF4-FFF2-40B4-BE49-F238E27FC236}">
-                <a16:creationId xmlns:a16="http://schemas.microsoft.com/office/drawing/2014/main" id="{863272FB-8142-4E82-B9EB-0A777B308CE9}"/>
+                <a16:creationId xmlns:a16="http://schemas.microsoft.com/office/drawing/2014/main" id="{94B43FA7-C83B-4467-AF4A-10BBEACE2538}"/>
               </a:ext>
             </a:extLst>
           </p:cNvPr>
@@ -5974,7 +5974,7 @@
           <p:cNvPr id="2" name="">
             <a:extLst xmlns:a="http://schemas.openxmlformats.org/drawingml/2006/main">
               <a:ext uri="{FF2B5EF4-FFF2-40B4-BE49-F238E27FC236}">
-                <a16:creationId xmlns:a16="http://schemas.microsoft.com/office/drawing/2014/main" id="{87031692-8CDD-4D4B-94B6-CB4192C1C569}"/>
+                <a16:creationId xmlns:a16="http://schemas.microsoft.com/office/drawing/2014/main" id="{192FE1A2-3446-4759-8634-6FE0872C56EF}"/>
               </a:ext>
             </a:extLst>
           </p:cNvPr>
@@ -6032,7 +6032,7 @@
           <p:cNvPr id="3" name="">
             <a:extLst xmlns:a="http://schemas.openxmlformats.org/drawingml/2006/main">
               <a:ext uri="{FF2B5EF4-FFF2-40B4-BE49-F238E27FC236}">
-                <a16:creationId xmlns:a16="http://schemas.microsoft.com/office/drawing/2014/main" id="{F79C094B-C617-41F1-90F2-E43FAC58976B}"/>
+                <a16:creationId xmlns:a16="http://schemas.microsoft.com/office/drawing/2014/main" id="{D0B05F37-237B-4B91-9517-47E508D57E8A}"/>
               </a:ext>
             </a:extLst>
           </p:cNvPr>
@@ -6090,7 +6090,7 @@
           <p:cNvPr id="4" name="">
             <a:extLst xmlns:a="http://schemas.openxmlformats.org/drawingml/2006/main">
               <a:ext uri="{FF2B5EF4-FFF2-40B4-BE49-F238E27FC236}">
-                <a16:creationId xmlns:a16="http://schemas.microsoft.com/office/drawing/2014/main" id="{D4B4AEA6-93AC-42B0-9893-FD705B9DC75A}"/>
+                <a16:creationId xmlns:a16="http://schemas.microsoft.com/office/drawing/2014/main" id="{ADDE7154-F214-4B48-B878-07B44D3E1495}"/>
               </a:ext>
             </a:extLst>
           </p:cNvPr>
@@ -6121,7 +6121,7 @@
           <p:cNvPr id="5" name="">
             <a:extLst xmlns:a="http://schemas.openxmlformats.org/drawingml/2006/main">
               <a:ext uri="{FF2B5EF4-FFF2-40B4-BE49-F238E27FC236}">
-                <a16:creationId xmlns:a16="http://schemas.microsoft.com/office/drawing/2014/main" id="{FFC723DB-5132-47F4-A1C8-624D2C9403B1}"/>
+                <a16:creationId xmlns:a16="http://schemas.microsoft.com/office/drawing/2014/main" id="{749B12F4-9BDC-40F2-B62F-55F8409D2F8E}"/>
               </a:ext>
             </a:extLst>
           </p:cNvPr>
@@ -6179,7 +6179,7 @@
           <p:cNvPr id="6" name="">
             <a:extLst xmlns:a="http://schemas.openxmlformats.org/drawingml/2006/main">
               <a:ext uri="{FF2B5EF4-FFF2-40B4-BE49-F238E27FC236}">
-                <a16:creationId xmlns:a16="http://schemas.microsoft.com/office/drawing/2014/main" id="{4CF6E396-9B70-4F0B-90F7-8C52D1AEB633}"/>
+                <a16:creationId xmlns:a16="http://schemas.microsoft.com/office/drawing/2014/main" id="{44C89E98-F8F4-45FC-BABA-754359292D9F}"/>
               </a:ext>
             </a:extLst>
           </p:cNvPr>
@@ -6237,7 +6237,7 @@
           <p:cNvPr id="7" name="">
             <a:extLst xmlns:a="http://schemas.openxmlformats.org/drawingml/2006/main">
               <a:ext uri="{FF2B5EF4-FFF2-40B4-BE49-F238E27FC236}">
-                <a16:creationId xmlns:a16="http://schemas.microsoft.com/office/drawing/2014/main" id="{31D7751F-9B11-484D-9115-5967DBE25213}"/>
+                <a16:creationId xmlns:a16="http://schemas.microsoft.com/office/drawing/2014/main" id="{7D9FADEC-DF14-4C7F-AD58-BB3D8F5BC458}"/>
               </a:ext>
             </a:extLst>
           </p:cNvPr>
@@ -6295,7 +6295,7 @@
           <p:cNvPr id="8" name="">
             <a:extLst xmlns:a="http://schemas.openxmlformats.org/drawingml/2006/main">
               <a:ext uri="{FF2B5EF4-FFF2-40B4-BE49-F238E27FC236}">
-                <a16:creationId xmlns:a16="http://schemas.microsoft.com/office/drawing/2014/main" id="{6CF065DE-0D17-4173-A975-102BD8997463}"/>
+                <a16:creationId xmlns:a16="http://schemas.microsoft.com/office/drawing/2014/main" id="{42FF778C-738E-41C7-87A9-1CFC7F3EBC90}"/>
               </a:ext>
             </a:extLst>
           </p:cNvPr>
@@ -6353,7 +6353,7 @@
           <p:cNvPr id="9" name="">
             <a:extLst xmlns:a="http://schemas.openxmlformats.org/drawingml/2006/main">
               <a:ext uri="{FF2B5EF4-FFF2-40B4-BE49-F238E27FC236}">
-                <a16:creationId xmlns:a16="http://schemas.microsoft.com/office/drawing/2014/main" id="{8C075C4B-3C2B-490F-9880-79D473194845}"/>
+                <a16:creationId xmlns:a16="http://schemas.microsoft.com/office/drawing/2014/main" id="{F5C66928-A078-4578-8CC5-ECF98EA5A60F}"/>
               </a:ext>
             </a:extLst>
           </p:cNvPr>
@@ -6411,7 +6411,7 @@
           <p:cNvPr id="10" name="">
             <a:extLst xmlns:a="http://schemas.openxmlformats.org/drawingml/2006/main">
               <a:ext uri="{FF2B5EF4-FFF2-40B4-BE49-F238E27FC236}">
-                <a16:creationId xmlns:a16="http://schemas.microsoft.com/office/drawing/2014/main" id="{E50CE7FC-2D81-4BC6-8585-12FEDE1007AB}"/>
+                <a16:creationId xmlns:a16="http://schemas.microsoft.com/office/drawing/2014/main" id="{8370AFC0-B469-43B4-8F96-5445673D4D8C}"/>
               </a:ext>
             </a:extLst>
           </p:cNvPr>
@@ -6469,7 +6469,7 @@
           <p:cNvPr id="11" name="">
             <a:extLst xmlns:a="http://schemas.openxmlformats.org/drawingml/2006/main">
               <a:ext uri="{FF2B5EF4-FFF2-40B4-BE49-F238E27FC236}">
-                <a16:creationId xmlns:a16="http://schemas.microsoft.com/office/drawing/2014/main" id="{62FAB8D7-B382-487D-91E7-4CFB8DB3E846}"/>
+                <a16:creationId xmlns:a16="http://schemas.microsoft.com/office/drawing/2014/main" id="{1F986BF6-A236-4DD5-9BFE-53141DE3F026}"/>
               </a:ext>
             </a:extLst>
           </p:cNvPr>
@@ -6527,7 +6527,7 @@
           <p:cNvPr id="12" name="">
             <a:extLst xmlns:a="http://schemas.openxmlformats.org/drawingml/2006/main">
               <a:ext uri="{FF2B5EF4-FFF2-40B4-BE49-F238E27FC236}">
-                <a16:creationId xmlns:a16="http://schemas.microsoft.com/office/drawing/2014/main" id="{C21E59F8-573D-4B45-806D-21501775F398}"/>
+                <a16:creationId xmlns:a16="http://schemas.microsoft.com/office/drawing/2014/main" id="{74ABE7BD-845B-4361-BAE7-848FC52A9DDA}"/>
               </a:ext>
             </a:extLst>
           </p:cNvPr>
@@ -6585,7 +6585,7 @@
           <p:cNvPr id="13" name="">
             <a:extLst xmlns:a="http://schemas.openxmlformats.org/drawingml/2006/main">
               <a:ext uri="{FF2B5EF4-FFF2-40B4-BE49-F238E27FC236}">
-                <a16:creationId xmlns:a16="http://schemas.microsoft.com/office/drawing/2014/main" id="{9EA547A2-24EA-4442-91E1-FBE6B51E2458}"/>
+                <a16:creationId xmlns:a16="http://schemas.microsoft.com/office/drawing/2014/main" id="{FFED21AE-8EA4-48F9-87D3-CA7755DA8D8E}"/>
               </a:ext>
             </a:extLst>
           </p:cNvPr>
@@ -6643,7 +6643,7 @@
           <p:cNvPr id="14" name="">
             <a:extLst xmlns:a="http://schemas.openxmlformats.org/drawingml/2006/main">
               <a:ext uri="{FF2B5EF4-FFF2-40B4-BE49-F238E27FC236}">
-                <a16:creationId xmlns:a16="http://schemas.microsoft.com/office/drawing/2014/main" id="{C91E9ACF-9B1F-44AC-A319-1190DF0546CC}"/>
+                <a16:creationId xmlns:a16="http://schemas.microsoft.com/office/drawing/2014/main" id="{578EEC4D-6DAD-48A9-9A79-85BA7BB565D3}"/>
               </a:ext>
             </a:extLst>
           </p:cNvPr>
@@ -6701,7 +6701,7 @@
           <p:cNvPr id="15" name="">
             <a:extLst xmlns:a="http://schemas.openxmlformats.org/drawingml/2006/main">
               <a:ext uri="{FF2B5EF4-FFF2-40B4-BE49-F238E27FC236}">
-                <a16:creationId xmlns:a16="http://schemas.microsoft.com/office/drawing/2014/main" id="{32C09709-0F24-4D40-80E0-23F64677636A}"/>
+                <a16:creationId xmlns:a16="http://schemas.microsoft.com/office/drawing/2014/main" id="{1A1356FC-1D19-498F-B3F4-BC8462BCDCC6}"/>
               </a:ext>
             </a:extLst>
           </p:cNvPr>
@@ -6759,7 +6759,7 @@
           <p:cNvPr id="16" name="">
             <a:extLst xmlns:a="http://schemas.openxmlformats.org/drawingml/2006/main">
               <a:ext uri="{FF2B5EF4-FFF2-40B4-BE49-F238E27FC236}">
-                <a16:creationId xmlns:a16="http://schemas.microsoft.com/office/drawing/2014/main" id="{FA19EF4D-F673-46CA-89AE-5A8856FBE348}"/>
+                <a16:creationId xmlns:a16="http://schemas.microsoft.com/office/drawing/2014/main" id="{74EEF40C-B4F9-4CD9-8A25-55BA6FBD156D}"/>
               </a:ext>
             </a:extLst>
           </p:cNvPr>
@@ -6817,7 +6817,7 @@
           <p:cNvPr id="17" name="">
             <a:extLst xmlns:a="http://schemas.openxmlformats.org/drawingml/2006/main">
               <a:ext uri="{FF2B5EF4-FFF2-40B4-BE49-F238E27FC236}">
-                <a16:creationId xmlns:a16="http://schemas.microsoft.com/office/drawing/2014/main" id="{A9272187-B98A-4EA6-9F93-92B907ED2817}"/>
+                <a16:creationId xmlns:a16="http://schemas.microsoft.com/office/drawing/2014/main" id="{9C48EA7E-549B-43D6-B641-BDC34EA5F0F8}"/>
               </a:ext>
             </a:extLst>
           </p:cNvPr>
@@ -6875,7 +6875,7 @@
           <p:cNvPr id="18" name="">
             <a:extLst xmlns:a="http://schemas.openxmlformats.org/drawingml/2006/main">
               <a:ext uri="{FF2B5EF4-FFF2-40B4-BE49-F238E27FC236}">
-                <a16:creationId xmlns:a16="http://schemas.microsoft.com/office/drawing/2014/main" id="{FE05A8CB-B2EA-490E-A590-EBAA9479B42F}"/>
+                <a16:creationId xmlns:a16="http://schemas.microsoft.com/office/drawing/2014/main" id="{63FC6B73-DBEC-48BA-8A83-24B0C3092BD1}"/>
               </a:ext>
             </a:extLst>
           </p:cNvPr>
@@ -6933,7 +6933,7 @@
           <p:cNvPr id="19" name="">
             <a:extLst xmlns:a="http://schemas.openxmlformats.org/drawingml/2006/main">
               <a:ext uri="{FF2B5EF4-FFF2-40B4-BE49-F238E27FC236}">
-                <a16:creationId xmlns:a16="http://schemas.microsoft.com/office/drawing/2014/main" id="{F8899EDE-081B-4F14-9D64-21F10DDDB34E}"/>
+                <a16:creationId xmlns:a16="http://schemas.microsoft.com/office/drawing/2014/main" id="{A8A362BC-A933-4887-9EBF-1D948CA5797B}"/>
               </a:ext>
             </a:extLst>
           </p:cNvPr>
@@ -6989,7 +6989,7 @@
     </p:spTree>
     <p:extLst>
       <p:ext uri="{BB962C8B-B14F-4D97-AF65-F5344CB8AC3E}">
-        <p14:creationId xmlns:p14="http://schemas.microsoft.com/office/powerpoint/2010/main" val="318033934"/>
+        <p14:creationId xmlns:p14="http://schemas.microsoft.com/office/powerpoint/2010/main" val="379025444"/>
       </p:ext>
     </p:extLst>
   </p:cSld>
@@ -7020,7 +7020,7 @@
           <p:cNvPr id="17" name="">
             <a:extLst xmlns:a="http://schemas.openxmlformats.org/drawingml/2006/main">
               <a:ext uri="{FF2B5EF4-FFF2-40B4-BE49-F238E27FC236}">
-                <a16:creationId xmlns:a16="http://schemas.microsoft.com/office/drawing/2014/main" id="{EFA98FCE-53A3-4294-924E-06A3BB17CC1D}"/>
+                <a16:creationId xmlns:a16="http://schemas.microsoft.com/office/drawing/2014/main" id="{DA571433-C35E-4B3D-8D6F-DE8A655F1A84}"/>
               </a:ext>
             </a:extLst>
           </p:cNvPr>
@@ -7051,7 +7051,7 @@
           <p:cNvPr id="2" name="">
             <a:extLst xmlns:a="http://schemas.openxmlformats.org/drawingml/2006/main">
               <a:ext uri="{FF2B5EF4-FFF2-40B4-BE49-F238E27FC236}">
-                <a16:creationId xmlns:a16="http://schemas.microsoft.com/office/drawing/2014/main" id="{1A056F3B-953C-4ACC-A2D2-093B51FE1E47}"/>
+                <a16:creationId xmlns:a16="http://schemas.microsoft.com/office/drawing/2014/main" id="{27B76C3E-13EA-400C-931B-ED7B27676A6F}"/>
               </a:ext>
             </a:extLst>
           </p:cNvPr>
@@ -7109,7 +7109,7 @@
           <p:cNvPr id="3" name="">
             <a:extLst xmlns:a="http://schemas.openxmlformats.org/drawingml/2006/main">
               <a:ext uri="{FF2B5EF4-FFF2-40B4-BE49-F238E27FC236}">
-                <a16:creationId xmlns:a16="http://schemas.microsoft.com/office/drawing/2014/main" id="{175CC59B-6E86-4F30-B311-06F758680437}"/>
+                <a16:creationId xmlns:a16="http://schemas.microsoft.com/office/drawing/2014/main" id="{1D4AC2FB-7509-4BA9-911A-2C6E95DC74DA}"/>
               </a:ext>
             </a:extLst>
           </p:cNvPr>
@@ -7167,7 +7167,7 @@
           <p:cNvPr id="4" name="">
             <a:extLst xmlns:a="http://schemas.openxmlformats.org/drawingml/2006/main">
               <a:ext uri="{FF2B5EF4-FFF2-40B4-BE49-F238E27FC236}">
-                <a16:creationId xmlns:a16="http://schemas.microsoft.com/office/drawing/2014/main" id="{2D0F28E4-840E-494D-91FF-1E60408E2254}"/>
+                <a16:creationId xmlns:a16="http://schemas.microsoft.com/office/drawing/2014/main" id="{A00EF2C1-F9E1-4FF4-AE8B-F375BD4104A4}"/>
               </a:ext>
             </a:extLst>
           </p:cNvPr>
@@ -7198,7 +7198,7 @@
           <p:cNvPr id="5" name="">
             <a:extLst xmlns:a="http://schemas.openxmlformats.org/drawingml/2006/main">
               <a:ext uri="{FF2B5EF4-FFF2-40B4-BE49-F238E27FC236}">
-                <a16:creationId xmlns:a16="http://schemas.microsoft.com/office/drawing/2014/main" id="{718FCBCD-09FF-43C0-95AA-273479BB6107}"/>
+                <a16:creationId xmlns:a16="http://schemas.microsoft.com/office/drawing/2014/main" id="{31B7CC28-5B2D-4692-B909-AF7E7248929E}"/>
               </a:ext>
             </a:extLst>
           </p:cNvPr>
@@ -7256,7 +7256,7 @@
           <p:cNvPr id="6" name="">
             <a:extLst xmlns:a="http://schemas.openxmlformats.org/drawingml/2006/main">
               <a:ext uri="{FF2B5EF4-FFF2-40B4-BE49-F238E27FC236}">
-                <a16:creationId xmlns:a16="http://schemas.microsoft.com/office/drawing/2014/main" id="{15C30015-0C90-43BC-ABA9-AEACD9836FFE}"/>
+                <a16:creationId xmlns:a16="http://schemas.microsoft.com/office/drawing/2014/main" id="{B6DC1987-BBF6-4B8E-9FA8-7AE3537FD3EB}"/>
               </a:ext>
             </a:extLst>
           </p:cNvPr>
@@ -7314,7 +7314,7 @@
           <p:cNvPr id="7" name="">
             <a:extLst xmlns:a="http://schemas.openxmlformats.org/drawingml/2006/main">
               <a:ext uri="{FF2B5EF4-FFF2-40B4-BE49-F238E27FC236}">
-                <a16:creationId xmlns:a16="http://schemas.microsoft.com/office/drawing/2014/main" id="{47BF5C37-DD5C-43B6-8AF3-9C74A626EAB5}"/>
+                <a16:creationId xmlns:a16="http://schemas.microsoft.com/office/drawing/2014/main" id="{A3D7176F-1209-410D-85D2-7DD90F93E652}"/>
               </a:ext>
             </a:extLst>
           </p:cNvPr>
@@ -7362,7 +7362,7 @@
                   <a:srgbClr val="A9BFC2"/>
                 </a:solidFill>
               </a:rPr>
-              <a:t>The repo separates an executable benchmark from models awaiting licensed data.</a:t>
+              <a:t>The demand model is fitted on synthetic history; real-data validation remains next.</a:t>
             </a:r>
           </a:p>
         </p:txBody>
@@ -7372,7 +7372,7 @@
           <p:cNvPr id="8" name="">
             <a:extLst xmlns:a="http://schemas.openxmlformats.org/drawingml/2006/main">
               <a:ext uri="{FF2B5EF4-FFF2-40B4-BE49-F238E27FC236}">
-                <a16:creationId xmlns:a16="http://schemas.microsoft.com/office/drawing/2014/main" id="{43363C65-F82D-4394-8E43-110156E1F6C5}"/>
+                <a16:creationId xmlns:a16="http://schemas.microsoft.com/office/drawing/2014/main" id="{4A26271E-7CBF-4CD2-B494-FA1176F05EAC}"/>
               </a:ext>
             </a:extLst>
           </p:cNvPr>
@@ -7403,7 +7403,7 @@
           <p:cNvPr id="9" name="">
             <a:extLst xmlns:a="http://schemas.openxmlformats.org/drawingml/2006/main">
               <a:ext uri="{FF2B5EF4-FFF2-40B4-BE49-F238E27FC236}">
-                <a16:creationId xmlns:a16="http://schemas.microsoft.com/office/drawing/2014/main" id="{34B2C50E-58A1-442B-A551-3B661C77870C}"/>
+                <a16:creationId xmlns:a16="http://schemas.microsoft.com/office/drawing/2014/main" id="{0B5BDC67-C79F-4D52-B295-08C83C2BE38B}"/>
               </a:ext>
             </a:extLst>
           </p:cNvPr>
@@ -7461,7 +7461,7 @@
           <p:cNvPr id="10" name="">
             <a:extLst xmlns:a="http://schemas.openxmlformats.org/drawingml/2006/main">
               <a:ext uri="{FF2B5EF4-FFF2-40B4-BE49-F238E27FC236}">
-                <a16:creationId xmlns:a16="http://schemas.microsoft.com/office/drawing/2014/main" id="{F626CE60-6FFE-41F8-94BB-0012806596BB}"/>
+                <a16:creationId xmlns:a16="http://schemas.microsoft.com/office/drawing/2014/main" id="{C95843CF-B75A-44A4-9B91-7F376FBC56AA}"/>
               </a:ext>
             </a:extLst>
           </p:cNvPr>
@@ -7509,7 +7509,7 @@
                   <a:srgbClr val="EFF7F4"/>
                 </a:solidFill>
               </a:rPr>
-              <a:t>Weekly seasonal benchmark runs now. Six direct ML candidates train after official hourly data is staged.</a:t>
+              <a:t>Six-horizon ridge model runs now. Synthetic test MAE: 513–641 MW. Real-data training path is ready.</a:t>
             </a:r>
           </a:p>
         </p:txBody>
@@ -7519,7 +7519,7 @@
           <p:cNvPr id="11" name="">
             <a:extLst xmlns:a="http://schemas.openxmlformats.org/drawingml/2006/main">
               <a:ext uri="{FF2B5EF4-FFF2-40B4-BE49-F238E27FC236}">
-                <a16:creationId xmlns:a16="http://schemas.microsoft.com/office/drawing/2014/main" id="{956AA58D-BC79-4F4D-A6CE-7FE333FDED53}"/>
+                <a16:creationId xmlns:a16="http://schemas.microsoft.com/office/drawing/2014/main" id="{AC72BACB-EF17-4417-8DFA-670D8CCD51F4}"/>
               </a:ext>
             </a:extLst>
           </p:cNvPr>
@@ -7550,7 +7550,7 @@
           <p:cNvPr id="12" name="">
             <a:extLst xmlns:a="http://schemas.openxmlformats.org/drawingml/2006/main">
               <a:ext uri="{FF2B5EF4-FFF2-40B4-BE49-F238E27FC236}">
-                <a16:creationId xmlns:a16="http://schemas.microsoft.com/office/drawing/2014/main" id="{6EEDB76E-AE0E-43B5-9C9E-6B5CAFB6216B}"/>
+                <a16:creationId xmlns:a16="http://schemas.microsoft.com/office/drawing/2014/main" id="{943CDC25-3CE2-4DB1-B04A-4CDC1C8AD352}"/>
               </a:ext>
             </a:extLst>
           </p:cNvPr>
@@ -7608,7 +7608,7 @@
           <p:cNvPr id="13" name="">
             <a:extLst xmlns:a="http://schemas.openxmlformats.org/drawingml/2006/main">
               <a:ext uri="{FF2B5EF4-FFF2-40B4-BE49-F238E27FC236}">
-                <a16:creationId xmlns:a16="http://schemas.microsoft.com/office/drawing/2014/main" id="{4C818A05-E2B6-4C52-814B-54BAD3834B2A}"/>
+                <a16:creationId xmlns:a16="http://schemas.microsoft.com/office/drawing/2014/main" id="{63C35F6A-E6EF-474F-8FF2-6CDBAA94EBBA}"/>
               </a:ext>
             </a:extLst>
           </p:cNvPr>
@@ -7666,7 +7666,7 @@
           <p:cNvPr id="14" name="">
             <a:extLst xmlns:a="http://schemas.openxmlformats.org/drawingml/2006/main">
               <a:ext uri="{FF2B5EF4-FFF2-40B4-BE49-F238E27FC236}">
-                <a16:creationId xmlns:a16="http://schemas.microsoft.com/office/drawing/2014/main" id="{1508FAE3-88E3-48DF-A365-676C894404A7}"/>
+                <a16:creationId xmlns:a16="http://schemas.microsoft.com/office/drawing/2014/main" id="{DC223485-C254-4AA3-9AA8-C5F198DB8DCA}"/>
               </a:ext>
             </a:extLst>
           </p:cNvPr>
@@ -7697,7 +7697,7 @@
           <p:cNvPr id="15" name="">
             <a:extLst xmlns:a="http://schemas.openxmlformats.org/drawingml/2006/main">
               <a:ext uri="{FF2B5EF4-FFF2-40B4-BE49-F238E27FC236}">
-                <a16:creationId xmlns:a16="http://schemas.microsoft.com/office/drawing/2014/main" id="{87694737-CD12-4821-815E-789943E18846}"/>
+                <a16:creationId xmlns:a16="http://schemas.microsoft.com/office/drawing/2014/main" id="{0662C439-147E-4930-BFB6-41FC9FE2EE5E}"/>
               </a:ext>
             </a:extLst>
           </p:cNvPr>
@@ -7755,7 +7755,7 @@
           <p:cNvPr id="16" name="">
             <a:extLst xmlns:a="http://schemas.openxmlformats.org/drawingml/2006/main">
               <a:ext uri="{FF2B5EF4-FFF2-40B4-BE49-F238E27FC236}">
-                <a16:creationId xmlns:a16="http://schemas.microsoft.com/office/drawing/2014/main" id="{C91DA0FC-4EE9-4C07-9BAA-F3269A2D9B6A}"/>
+                <a16:creationId xmlns:a16="http://schemas.microsoft.com/office/drawing/2014/main" id="{C3B7D6C5-A43A-425F-8A34-B52B52AD451C}"/>
               </a:ext>
             </a:extLst>
           </p:cNvPr>
@@ -7811,7 +7811,7 @@
     </p:spTree>
     <p:extLst>
       <p:ext uri="{BB962C8B-B14F-4D97-AF65-F5344CB8AC3E}">
-        <p14:creationId xmlns:p14="http://schemas.microsoft.com/office/powerpoint/2010/main" val="2135936924"/>
+        <p14:creationId xmlns:p14="http://schemas.microsoft.com/office/powerpoint/2010/main" val="1182662713"/>
       </p:ext>
     </p:extLst>
   </p:cSld>
@@ -7842,7 +7842,7 @@
           <p:cNvPr id="21" name="">
             <a:extLst xmlns:a="http://schemas.openxmlformats.org/drawingml/2006/main">
               <a:ext uri="{FF2B5EF4-FFF2-40B4-BE49-F238E27FC236}">
-                <a16:creationId xmlns:a16="http://schemas.microsoft.com/office/drawing/2014/main" id="{0F2F0FDD-ECEC-405F-B670-5B64BA69578E}"/>
+                <a16:creationId xmlns:a16="http://schemas.microsoft.com/office/drawing/2014/main" id="{51E855AD-5052-4A19-9614-E6C5D6A90FE3}"/>
               </a:ext>
             </a:extLst>
           </p:cNvPr>
@@ -7873,7 +7873,7 @@
           <p:cNvPr id="2" name="">
             <a:extLst xmlns:a="http://schemas.openxmlformats.org/drawingml/2006/main">
               <a:ext uri="{FF2B5EF4-FFF2-40B4-BE49-F238E27FC236}">
-                <a16:creationId xmlns:a16="http://schemas.microsoft.com/office/drawing/2014/main" id="{57D04552-A844-402B-BD4D-82E8CCBD8980}"/>
+                <a16:creationId xmlns:a16="http://schemas.microsoft.com/office/drawing/2014/main" id="{A60E5D90-27AC-4D46-A54D-3E5A0F622D6F}"/>
               </a:ext>
             </a:extLst>
           </p:cNvPr>
@@ -7931,7 +7931,7 @@
           <p:cNvPr id="3" name="">
             <a:extLst xmlns:a="http://schemas.openxmlformats.org/drawingml/2006/main">
               <a:ext uri="{FF2B5EF4-FFF2-40B4-BE49-F238E27FC236}">
-                <a16:creationId xmlns:a16="http://schemas.microsoft.com/office/drawing/2014/main" id="{D8077285-658E-44F4-9809-33C8988B213A}"/>
+                <a16:creationId xmlns:a16="http://schemas.microsoft.com/office/drawing/2014/main" id="{F4FCEEB3-825D-4CE0-9F6C-475EFCC1DA2D}"/>
               </a:ext>
             </a:extLst>
           </p:cNvPr>
@@ -7989,7 +7989,7 @@
           <p:cNvPr id="4" name="">
             <a:extLst xmlns:a="http://schemas.openxmlformats.org/drawingml/2006/main">
               <a:ext uri="{FF2B5EF4-FFF2-40B4-BE49-F238E27FC236}">
-                <a16:creationId xmlns:a16="http://schemas.microsoft.com/office/drawing/2014/main" id="{28BB4FF7-726B-41AA-8221-53C75AE3A939}"/>
+                <a16:creationId xmlns:a16="http://schemas.microsoft.com/office/drawing/2014/main" id="{F7E0D866-B958-4418-BFBB-742205F189A7}"/>
               </a:ext>
             </a:extLst>
           </p:cNvPr>
@@ -8020,7 +8020,7 @@
           <p:cNvPr id="5" name="">
             <a:extLst xmlns:a="http://schemas.openxmlformats.org/drawingml/2006/main">
               <a:ext uri="{FF2B5EF4-FFF2-40B4-BE49-F238E27FC236}">
-                <a16:creationId xmlns:a16="http://schemas.microsoft.com/office/drawing/2014/main" id="{CE82E428-1710-40DB-A3F5-A3E659415849}"/>
+                <a16:creationId xmlns:a16="http://schemas.microsoft.com/office/drawing/2014/main" id="{61E495A4-2372-4B52-A678-FD132E55723D}"/>
               </a:ext>
             </a:extLst>
           </p:cNvPr>
@@ -8078,7 +8078,7 @@
           <p:cNvPr id="6" name="">
             <a:extLst xmlns:a="http://schemas.openxmlformats.org/drawingml/2006/main">
               <a:ext uri="{FF2B5EF4-FFF2-40B4-BE49-F238E27FC236}">
-                <a16:creationId xmlns:a16="http://schemas.microsoft.com/office/drawing/2014/main" id="{C1856000-EF48-41DD-81ED-DFE00EB6B314}"/>
+                <a16:creationId xmlns:a16="http://schemas.microsoft.com/office/drawing/2014/main" id="{657E2C0E-DAF1-41B0-9355-78CDCA481D90}"/>
               </a:ext>
             </a:extLst>
           </p:cNvPr>
@@ -8136,7 +8136,7 @@
           <p:cNvPr id="7" name="">
             <a:extLst xmlns:a="http://schemas.openxmlformats.org/drawingml/2006/main">
               <a:ext uri="{FF2B5EF4-FFF2-40B4-BE49-F238E27FC236}">
-                <a16:creationId xmlns:a16="http://schemas.microsoft.com/office/drawing/2014/main" id="{75936D1F-4FC7-4988-8F09-B922FA240537}"/>
+                <a16:creationId xmlns:a16="http://schemas.microsoft.com/office/drawing/2014/main" id="{0A80DC1D-1B51-4694-A64F-61D675E30162}"/>
               </a:ext>
             </a:extLst>
           </p:cNvPr>
@@ -8194,7 +8194,7 @@
           <p:cNvPr id="8" name="">
             <a:extLst xmlns:a="http://schemas.openxmlformats.org/drawingml/2006/main">
               <a:ext uri="{FF2B5EF4-FFF2-40B4-BE49-F238E27FC236}">
-                <a16:creationId xmlns:a16="http://schemas.microsoft.com/office/drawing/2014/main" id="{01036503-3EC6-41CB-8794-7B500C32CD81}"/>
+                <a16:creationId xmlns:a16="http://schemas.microsoft.com/office/drawing/2014/main" id="{32DCEC66-A753-4E11-A358-2B5BFBB54C57}"/>
               </a:ext>
             </a:extLst>
           </p:cNvPr>
@@ -8225,7 +8225,7 @@
           <p:cNvPr id="9" name="">
             <a:extLst xmlns:a="http://schemas.openxmlformats.org/drawingml/2006/main">
               <a:ext uri="{FF2B5EF4-FFF2-40B4-BE49-F238E27FC236}">
-                <a16:creationId xmlns:a16="http://schemas.microsoft.com/office/drawing/2014/main" id="{0AF0A03D-5690-4C23-98AD-942633CECE8C}"/>
+                <a16:creationId xmlns:a16="http://schemas.microsoft.com/office/drawing/2014/main" id="{7D0DEC90-D75B-45AE-BE02-FD648B42F244}"/>
               </a:ext>
             </a:extLst>
           </p:cNvPr>
@@ -8283,7 +8283,7 @@
           <p:cNvPr id="10" name="">
             <a:extLst xmlns:a="http://schemas.openxmlformats.org/drawingml/2006/main">
               <a:ext uri="{FF2B5EF4-FFF2-40B4-BE49-F238E27FC236}">
-                <a16:creationId xmlns:a16="http://schemas.microsoft.com/office/drawing/2014/main" id="{7D9271EF-582A-4C44-BCB3-FB02F27A2AF5}"/>
+                <a16:creationId xmlns:a16="http://schemas.microsoft.com/office/drawing/2014/main" id="{DE163B0E-0686-4CEC-89E0-91D2A1A06BE9}"/>
               </a:ext>
             </a:extLst>
           </p:cNvPr>
@@ -8341,7 +8341,7 @@
           <p:cNvPr id="11" name="">
             <a:extLst xmlns:a="http://schemas.openxmlformats.org/drawingml/2006/main">
               <a:ext uri="{FF2B5EF4-FFF2-40B4-BE49-F238E27FC236}">
-                <a16:creationId xmlns:a16="http://schemas.microsoft.com/office/drawing/2014/main" id="{CBA22F99-0E7A-4256-9BEC-6E8BB66AB23E}"/>
+                <a16:creationId xmlns:a16="http://schemas.microsoft.com/office/drawing/2014/main" id="{87DFDDAA-F69F-4CDA-9F8B-074F153E85C4}"/>
               </a:ext>
             </a:extLst>
           </p:cNvPr>
@@ -8372,7 +8372,7 @@
           <p:cNvPr id="12" name="">
             <a:extLst xmlns:a="http://schemas.openxmlformats.org/drawingml/2006/main">
               <a:ext uri="{FF2B5EF4-FFF2-40B4-BE49-F238E27FC236}">
-                <a16:creationId xmlns:a16="http://schemas.microsoft.com/office/drawing/2014/main" id="{6B5E9F96-5DE9-43C3-9212-210C5FE6750A}"/>
+                <a16:creationId xmlns:a16="http://schemas.microsoft.com/office/drawing/2014/main" id="{70A5A3D3-707F-431A-BFF0-5CDEB2E1EFDE}"/>
               </a:ext>
             </a:extLst>
           </p:cNvPr>
@@ -8430,7 +8430,7 @@
           <p:cNvPr id="13" name="">
             <a:extLst xmlns:a="http://schemas.openxmlformats.org/drawingml/2006/main">
               <a:ext uri="{FF2B5EF4-FFF2-40B4-BE49-F238E27FC236}">
-                <a16:creationId xmlns:a16="http://schemas.microsoft.com/office/drawing/2014/main" id="{AC2931DA-78A5-4DD6-BE01-36404CCB5643}"/>
+                <a16:creationId xmlns:a16="http://schemas.microsoft.com/office/drawing/2014/main" id="{3D0A15B7-E8F3-4F12-AFB6-EE2CC2D2CA1B}"/>
               </a:ext>
             </a:extLst>
           </p:cNvPr>
@@ -8488,7 +8488,7 @@
           <p:cNvPr id="14" name="">
             <a:extLst xmlns:a="http://schemas.openxmlformats.org/drawingml/2006/main">
               <a:ext uri="{FF2B5EF4-FFF2-40B4-BE49-F238E27FC236}">
-                <a16:creationId xmlns:a16="http://schemas.microsoft.com/office/drawing/2014/main" id="{4D5721AD-8A53-4AE9-A0F6-BD7708849F64}"/>
+                <a16:creationId xmlns:a16="http://schemas.microsoft.com/office/drawing/2014/main" id="{E33A4C5A-C161-4A39-AE59-5A6EB8B44710}"/>
               </a:ext>
             </a:extLst>
           </p:cNvPr>
@@ -8519,7 +8519,7 @@
           <p:cNvPr id="15" name="">
             <a:extLst xmlns:a="http://schemas.openxmlformats.org/drawingml/2006/main">
               <a:ext uri="{FF2B5EF4-FFF2-40B4-BE49-F238E27FC236}">
-                <a16:creationId xmlns:a16="http://schemas.microsoft.com/office/drawing/2014/main" id="{380217BD-5DDF-47F9-A6CF-5A74BAA3BCAC}"/>
+                <a16:creationId xmlns:a16="http://schemas.microsoft.com/office/drawing/2014/main" id="{FBA2084F-434F-41F3-BF53-300F126340C8}"/>
               </a:ext>
             </a:extLst>
           </p:cNvPr>
@@ -8577,7 +8577,7 @@
           <p:cNvPr id="16" name="">
             <a:extLst xmlns:a="http://schemas.openxmlformats.org/drawingml/2006/main">
               <a:ext uri="{FF2B5EF4-FFF2-40B4-BE49-F238E27FC236}">
-                <a16:creationId xmlns:a16="http://schemas.microsoft.com/office/drawing/2014/main" id="{B141D7DD-6C82-4A34-B5A3-74C2D3ED0A2B}"/>
+                <a16:creationId xmlns:a16="http://schemas.microsoft.com/office/drawing/2014/main" id="{AD90E346-DFE5-4A84-BDA3-22679DF7B0BE}"/>
               </a:ext>
             </a:extLst>
           </p:cNvPr>
@@ -8635,7 +8635,7 @@
           <p:cNvPr id="17" name="">
             <a:extLst xmlns:a="http://schemas.openxmlformats.org/drawingml/2006/main">
               <a:ext uri="{FF2B5EF4-FFF2-40B4-BE49-F238E27FC236}">
-                <a16:creationId xmlns:a16="http://schemas.microsoft.com/office/drawing/2014/main" id="{CC20D0BB-B7EC-4A6E-B8F5-5D50709CC43C}"/>
+                <a16:creationId xmlns:a16="http://schemas.microsoft.com/office/drawing/2014/main" id="{09C6F6C2-10E0-4509-B129-0CCF2612405D}"/>
               </a:ext>
             </a:extLst>
           </p:cNvPr>
@@ -8666,7 +8666,7 @@
           <p:cNvPr id="18" name="">
             <a:extLst xmlns:a="http://schemas.openxmlformats.org/drawingml/2006/main">
               <a:ext uri="{FF2B5EF4-FFF2-40B4-BE49-F238E27FC236}">
-                <a16:creationId xmlns:a16="http://schemas.microsoft.com/office/drawing/2014/main" id="{3976947F-795C-4C21-AEB8-F5CCB478486C}"/>
+                <a16:creationId xmlns:a16="http://schemas.microsoft.com/office/drawing/2014/main" id="{11EA98FA-A859-45AC-9F46-9705BC977BAD}"/>
               </a:ext>
             </a:extLst>
           </p:cNvPr>
@@ -8724,7 +8724,7 @@
           <p:cNvPr id="19" name="">
             <a:extLst xmlns:a="http://schemas.openxmlformats.org/drawingml/2006/main">
               <a:ext uri="{FF2B5EF4-FFF2-40B4-BE49-F238E27FC236}">
-                <a16:creationId xmlns:a16="http://schemas.microsoft.com/office/drawing/2014/main" id="{566ED25C-7493-4697-944B-95C287E7492D}"/>
+                <a16:creationId xmlns:a16="http://schemas.microsoft.com/office/drawing/2014/main" id="{C3378580-2767-4C42-A250-674992C0D4D2}"/>
               </a:ext>
             </a:extLst>
           </p:cNvPr>
@@ -8782,7 +8782,7 @@
           <p:cNvPr id="20" name="">
             <a:extLst xmlns:a="http://schemas.openxmlformats.org/drawingml/2006/main">
               <a:ext uri="{FF2B5EF4-FFF2-40B4-BE49-F238E27FC236}">
-                <a16:creationId xmlns:a16="http://schemas.microsoft.com/office/drawing/2014/main" id="{F32DB069-DB1C-499D-AF15-470D88A5CF9F}"/>
+                <a16:creationId xmlns:a16="http://schemas.microsoft.com/office/drawing/2014/main" id="{22C8B7D7-C9CC-4D0F-A2B1-239629EF2191}"/>
               </a:ext>
             </a:extLst>
           </p:cNvPr>
@@ -8838,7 +8838,7 @@
     </p:spTree>
     <p:extLst>
       <p:ext uri="{BB962C8B-B14F-4D97-AF65-F5344CB8AC3E}">
-        <p14:creationId xmlns:p14="http://schemas.microsoft.com/office/powerpoint/2010/main" val="25744600"/>
+        <p14:creationId xmlns:p14="http://schemas.microsoft.com/office/powerpoint/2010/main" val="286681219"/>
       </p:ext>
     </p:extLst>
   </p:cSld>
@@ -8869,7 +8869,7 @@
           <p:cNvPr id="13" name="">
             <a:extLst xmlns:a="http://schemas.openxmlformats.org/drawingml/2006/main">
               <a:ext uri="{FF2B5EF4-FFF2-40B4-BE49-F238E27FC236}">
-                <a16:creationId xmlns:a16="http://schemas.microsoft.com/office/drawing/2014/main" id="{F0C6F8DE-CD9C-46BC-9C84-59ECADD8ACC7}"/>
+                <a16:creationId xmlns:a16="http://schemas.microsoft.com/office/drawing/2014/main" id="{5E948013-ED4D-48C9-8743-BE5860FCE3E5}"/>
               </a:ext>
             </a:extLst>
           </p:cNvPr>
@@ -8900,7 +8900,7 @@
           <p:cNvPr id="2" name="">
             <a:extLst xmlns:a="http://schemas.openxmlformats.org/drawingml/2006/main">
               <a:ext uri="{FF2B5EF4-FFF2-40B4-BE49-F238E27FC236}">
-                <a16:creationId xmlns:a16="http://schemas.microsoft.com/office/drawing/2014/main" id="{381DE7D2-62A2-4C23-8ABD-7C52E8B19823}"/>
+                <a16:creationId xmlns:a16="http://schemas.microsoft.com/office/drawing/2014/main" id="{75DB5005-CF59-4563-A0D3-4722A337BF3B}"/>
               </a:ext>
             </a:extLst>
           </p:cNvPr>
@@ -8958,7 +8958,7 @@
           <p:cNvPr id="3" name="">
             <a:extLst xmlns:a="http://schemas.openxmlformats.org/drawingml/2006/main">
               <a:ext uri="{FF2B5EF4-FFF2-40B4-BE49-F238E27FC236}">
-                <a16:creationId xmlns:a16="http://schemas.microsoft.com/office/drawing/2014/main" id="{BF77DA16-7BEB-4443-9553-D4F2A1FDB27F}"/>
+                <a16:creationId xmlns:a16="http://schemas.microsoft.com/office/drawing/2014/main" id="{BF0EF900-81EE-4C36-83E4-FCF14BF39DA5}"/>
               </a:ext>
             </a:extLst>
           </p:cNvPr>
@@ -9016,7 +9016,7 @@
           <p:cNvPr id="4" name="">
             <a:extLst xmlns:a="http://schemas.openxmlformats.org/drawingml/2006/main">
               <a:ext uri="{FF2B5EF4-FFF2-40B4-BE49-F238E27FC236}">
-                <a16:creationId xmlns:a16="http://schemas.microsoft.com/office/drawing/2014/main" id="{56C65F01-E686-4BDA-A4F1-BEB2CB5AFD84}"/>
+                <a16:creationId xmlns:a16="http://schemas.microsoft.com/office/drawing/2014/main" id="{F6E7B646-A9D6-47C9-B774-ABB41BCF3A56}"/>
               </a:ext>
             </a:extLst>
           </p:cNvPr>
@@ -9047,7 +9047,7 @@
           <p:cNvPr id="5" name="">
             <a:extLst xmlns:a="http://schemas.openxmlformats.org/drawingml/2006/main">
               <a:ext uri="{FF2B5EF4-FFF2-40B4-BE49-F238E27FC236}">
-                <a16:creationId xmlns:a16="http://schemas.microsoft.com/office/drawing/2014/main" id="{40242D00-BE0A-4BDB-8F05-19BB037259C1}"/>
+                <a16:creationId xmlns:a16="http://schemas.microsoft.com/office/drawing/2014/main" id="{BFA17EA8-9325-4407-9062-91E45E4AA10C}"/>
               </a:ext>
             </a:extLst>
           </p:cNvPr>
@@ -9105,7 +9105,7 @@
           <p:cNvPr id="6" name="">
             <a:extLst xmlns:a="http://schemas.openxmlformats.org/drawingml/2006/main">
               <a:ext uri="{FF2B5EF4-FFF2-40B4-BE49-F238E27FC236}">
-                <a16:creationId xmlns:a16="http://schemas.microsoft.com/office/drawing/2014/main" id="{32B92E79-0BD9-4736-94BE-4BC4EAB2F565}"/>
+                <a16:creationId xmlns:a16="http://schemas.microsoft.com/office/drawing/2014/main" id="{27AF745D-81D9-485C-B94D-C3E7EEAE2350}"/>
               </a:ext>
             </a:extLst>
           </p:cNvPr>
@@ -9163,7 +9163,7 @@
           <p:cNvPr id="7" name="">
             <a:extLst xmlns:a="http://schemas.openxmlformats.org/drawingml/2006/main">
               <a:ext uri="{FF2B5EF4-FFF2-40B4-BE49-F238E27FC236}">
-                <a16:creationId xmlns:a16="http://schemas.microsoft.com/office/drawing/2014/main" id="{4DBC3614-3408-4173-932F-4D6D3AE28659}"/>
+                <a16:creationId xmlns:a16="http://schemas.microsoft.com/office/drawing/2014/main" id="{C126A572-5AAE-469B-BE72-D5A128CDAD75}"/>
               </a:ext>
             </a:extLst>
           </p:cNvPr>
@@ -9221,7 +9221,7 @@
           <p:cNvPr id="8" name="">
             <a:extLst xmlns:a="http://schemas.openxmlformats.org/drawingml/2006/main">
               <a:ext uri="{FF2B5EF4-FFF2-40B4-BE49-F238E27FC236}">
-                <a16:creationId xmlns:a16="http://schemas.microsoft.com/office/drawing/2014/main" id="{F5D202B9-7FAC-4FE5-B021-E564C2688AD9}"/>
+                <a16:creationId xmlns:a16="http://schemas.microsoft.com/office/drawing/2014/main" id="{162C9F4E-4AD2-49B0-BB36-3D47ECDB4665}"/>
               </a:ext>
             </a:extLst>
           </p:cNvPr>
@@ -9279,7 +9279,7 @@
           <p:cNvPr id="9" name="">
             <a:extLst xmlns:a="http://schemas.openxmlformats.org/drawingml/2006/main">
               <a:ext uri="{FF2B5EF4-FFF2-40B4-BE49-F238E27FC236}">
-                <a16:creationId xmlns:a16="http://schemas.microsoft.com/office/drawing/2014/main" id="{50936A21-46A5-4AE1-A745-6004DFB136C4}"/>
+                <a16:creationId xmlns:a16="http://schemas.microsoft.com/office/drawing/2014/main" id="{92DB7DDF-B653-4034-BD13-0CED9DCF590F}"/>
               </a:ext>
             </a:extLst>
           </p:cNvPr>
@@ -9310,7 +9310,7 @@
           <p:cNvPr id="10" name="">
             <a:extLst xmlns:a="http://schemas.openxmlformats.org/drawingml/2006/main">
               <a:ext uri="{FF2B5EF4-FFF2-40B4-BE49-F238E27FC236}">
-                <a16:creationId xmlns:a16="http://schemas.microsoft.com/office/drawing/2014/main" id="{B4FD6174-E683-4280-9EA6-7E9E946614FA}"/>
+                <a16:creationId xmlns:a16="http://schemas.microsoft.com/office/drawing/2014/main" id="{56FDE163-6D6C-4386-8029-F86CC5AC5AB2}"/>
               </a:ext>
             </a:extLst>
           </p:cNvPr>
@@ -9368,7 +9368,7 @@
           <p:cNvPr id="11" name="">
             <a:extLst xmlns:a="http://schemas.openxmlformats.org/drawingml/2006/main">
               <a:ext uri="{FF2B5EF4-FFF2-40B4-BE49-F238E27FC236}">
-                <a16:creationId xmlns:a16="http://schemas.microsoft.com/office/drawing/2014/main" id="{E7F61337-8D65-4DB8-8FD0-549CB2E9FFDE}"/>
+                <a16:creationId xmlns:a16="http://schemas.microsoft.com/office/drawing/2014/main" id="{0A493C65-87BB-47C6-AE24-25C431EEE3D3}"/>
               </a:ext>
             </a:extLst>
           </p:cNvPr>
@@ -9399,7 +9399,7 @@
           <p:cNvPr id="12" name="">
             <a:extLst xmlns:a="http://schemas.openxmlformats.org/drawingml/2006/main">
               <a:ext uri="{FF2B5EF4-FFF2-40B4-BE49-F238E27FC236}">
-                <a16:creationId xmlns:a16="http://schemas.microsoft.com/office/drawing/2014/main" id="{815C0BFD-2630-4835-8686-A7F4DF61A3C6}"/>
+                <a16:creationId xmlns:a16="http://schemas.microsoft.com/office/drawing/2014/main" id="{1DBB789A-7EAA-4EF4-A205-41BC93FD2197}"/>
               </a:ext>
             </a:extLst>
           </p:cNvPr>
@@ -9455,7 +9455,7 @@
     </p:spTree>
     <p:extLst>
       <p:ext uri="{BB962C8B-B14F-4D97-AF65-F5344CB8AC3E}">
-        <p14:creationId xmlns:p14="http://schemas.microsoft.com/office/powerpoint/2010/main" val="2000323859"/>
+        <p14:creationId xmlns:p14="http://schemas.microsoft.com/office/powerpoint/2010/main" val="1532475415"/>
       </p:ext>
     </p:extLst>
   </p:cSld>
@@ -9486,7 +9486,7 @@
           <p:cNvPr id="10" name="">
             <a:extLst xmlns:a="http://schemas.openxmlformats.org/drawingml/2006/main">
               <a:ext uri="{FF2B5EF4-FFF2-40B4-BE49-F238E27FC236}">
-                <a16:creationId xmlns:a16="http://schemas.microsoft.com/office/drawing/2014/main" id="{549491A6-1557-42DF-B496-062E55988A14}"/>
+                <a16:creationId xmlns:a16="http://schemas.microsoft.com/office/drawing/2014/main" id="{FE5DAD1F-F452-4827-B319-1CC6F37A2A1E}"/>
               </a:ext>
             </a:extLst>
           </p:cNvPr>
@@ -9517,7 +9517,7 @@
           <p:cNvPr id="2" name="">
             <a:extLst xmlns:a="http://schemas.openxmlformats.org/drawingml/2006/main">
               <a:ext uri="{FF2B5EF4-FFF2-40B4-BE49-F238E27FC236}">
-                <a16:creationId xmlns:a16="http://schemas.microsoft.com/office/drawing/2014/main" id="{3C40556B-6E80-444C-86D7-07E1C78AD3D9}"/>
+                <a16:creationId xmlns:a16="http://schemas.microsoft.com/office/drawing/2014/main" id="{2F40576A-18CC-44CF-8C4E-A087AECAEC96}"/>
               </a:ext>
             </a:extLst>
           </p:cNvPr>
@@ -9575,7 +9575,7 @@
           <p:cNvPr id="3" name="">
             <a:extLst xmlns:a="http://schemas.openxmlformats.org/drawingml/2006/main">
               <a:ext uri="{FF2B5EF4-FFF2-40B4-BE49-F238E27FC236}">
-                <a16:creationId xmlns:a16="http://schemas.microsoft.com/office/drawing/2014/main" id="{03666342-F664-4C9F-8CFB-F71EDA12F395}"/>
+                <a16:creationId xmlns:a16="http://schemas.microsoft.com/office/drawing/2014/main" id="{BB3D1939-2B3D-445B-B1E0-49CE44296F19}"/>
               </a:ext>
             </a:extLst>
           </p:cNvPr>
@@ -9633,7 +9633,7 @@
           <p:cNvPr id="4" name="">
             <a:extLst xmlns:a="http://schemas.openxmlformats.org/drawingml/2006/main">
               <a:ext uri="{FF2B5EF4-FFF2-40B4-BE49-F238E27FC236}">
-                <a16:creationId xmlns:a16="http://schemas.microsoft.com/office/drawing/2014/main" id="{5D08CC7E-64E5-4409-9F25-15FC04F5BB8A}"/>
+                <a16:creationId xmlns:a16="http://schemas.microsoft.com/office/drawing/2014/main" id="{B836FEB0-C3B2-4537-9A2C-98379BA3ED1B}"/>
               </a:ext>
             </a:extLst>
           </p:cNvPr>
@@ -9664,7 +9664,7 @@
           <p:cNvPr id="5" name="">
             <a:extLst xmlns:a="http://schemas.openxmlformats.org/drawingml/2006/main">
               <a:ext uri="{FF2B5EF4-FFF2-40B4-BE49-F238E27FC236}">
-                <a16:creationId xmlns:a16="http://schemas.microsoft.com/office/drawing/2014/main" id="{790C03DA-1CBA-4EC6-9BE3-4B317FA7C7CE}"/>
+                <a16:creationId xmlns:a16="http://schemas.microsoft.com/office/drawing/2014/main" id="{E0A49E91-77B7-44DD-B47A-06385EC12A3E}"/>
               </a:ext>
             </a:extLst>
           </p:cNvPr>
@@ -9722,7 +9722,7 @@
           <p:cNvPr id="6" name="">
             <a:extLst xmlns:a="http://schemas.openxmlformats.org/drawingml/2006/main">
               <a:ext uri="{FF2B5EF4-FFF2-40B4-BE49-F238E27FC236}">
-                <a16:creationId xmlns:a16="http://schemas.microsoft.com/office/drawing/2014/main" id="{778B2849-18A8-4043-B9E8-65F277AAAE77}"/>
+                <a16:creationId xmlns:a16="http://schemas.microsoft.com/office/drawing/2014/main" id="{DB9D4E36-1382-4E2F-9B35-9BA65CAD1E07}"/>
               </a:ext>
             </a:extLst>
           </p:cNvPr>
@@ -9780,7 +9780,7 @@
           <p:cNvPr id="7" name="">
             <a:extLst xmlns:a="http://schemas.openxmlformats.org/drawingml/2006/main">
               <a:ext uri="{FF2B5EF4-FFF2-40B4-BE49-F238E27FC236}">
-                <a16:creationId xmlns:a16="http://schemas.microsoft.com/office/drawing/2014/main" id="{EAF87F7F-711C-44C1-8CE1-A909220EC5A3}"/>
+                <a16:creationId xmlns:a16="http://schemas.microsoft.com/office/drawing/2014/main" id="{945E6821-F5D4-4993-8BC3-536A8807413B}"/>
               </a:ext>
             </a:extLst>
           </p:cNvPr>
@@ -9838,7 +9838,7 @@
           <p:cNvPr id="8" name="">
             <a:extLst xmlns:a="http://schemas.openxmlformats.org/drawingml/2006/main">
               <a:ext uri="{FF2B5EF4-FFF2-40B4-BE49-F238E27FC236}">
-                <a16:creationId xmlns:a16="http://schemas.microsoft.com/office/drawing/2014/main" id="{9A27CD19-23ED-45DF-AF49-0AD2803849A9}"/>
+                <a16:creationId xmlns:a16="http://schemas.microsoft.com/office/drawing/2014/main" id="{B6F88F7F-37EC-4B07-981D-AB43B481A0E8}"/>
               </a:ext>
             </a:extLst>
           </p:cNvPr>
@@ -9869,7 +9869,7 @@
           <p:cNvPr id="9" name="">
             <a:extLst xmlns:a="http://schemas.openxmlformats.org/drawingml/2006/main">
               <a:ext uri="{FF2B5EF4-FFF2-40B4-BE49-F238E27FC236}">
-                <a16:creationId xmlns:a16="http://schemas.microsoft.com/office/drawing/2014/main" id="{2412B01E-2CA9-48FC-AE01-5E725354B7C5}"/>
+                <a16:creationId xmlns:a16="http://schemas.microsoft.com/office/drawing/2014/main" id="{9FB4C564-2FC6-4A87-8F9A-A1D3447452C8}"/>
               </a:ext>
             </a:extLst>
           </p:cNvPr>
@@ -9925,7 +9925,7 @@
     </p:spTree>
     <p:extLst>
       <p:ext uri="{BB962C8B-B14F-4D97-AF65-F5344CB8AC3E}">
-        <p14:creationId xmlns:p14="http://schemas.microsoft.com/office/powerpoint/2010/main" val="1386644807"/>
+        <p14:creationId xmlns:p14="http://schemas.microsoft.com/office/powerpoint/2010/main" val="1557588524"/>
       </p:ext>
     </p:extLst>
   </p:cSld>

</xml_diff>